<commit_message>
chore: commit externally-updated relink-presentation.pptx
Co-Authored-By: Claude Sonnet 5 <noreply@anthropic.com>
</commit_message>
<xml_diff>
--- a/presentation/relink-presentation.pptx
+++ b/presentation/relink-presentation.pptx
@@ -1,22 +1,45 @@
 
 <file path=ppt/presentation.xml><?xml version="1.0" encoding="utf-8"?>
-<p:presentation xmlns:a="http://schemas.openxmlformats.org/drawingml/2006/main" xmlns:r="http://schemas.openxmlformats.org/officeDocument/2006/relationships" xmlns:p="http://schemas.openxmlformats.org/presentationml/2006/main" saveSubsetFonts="1" autoCompressPictures="0">
+<p:presentation xmlns:a="http://schemas.openxmlformats.org/drawingml/2006/main" xmlns:r="http://schemas.openxmlformats.org/officeDocument/2006/relationships" xmlns:p="http://schemas.openxmlformats.org/presentationml/2006/main" embedTrueTypeFonts="1" autoCompressPictures="0">
   <p:sldMasterIdLst>
     <p:sldMasterId id="2147483648" r:id="rId1"/>
   </p:sldMasterIdLst>
   <p:sldIdLst>
-    <p:sldId id="256" r:id="rId7"/>
-    <p:sldId id="257" r:id="rId8"/>
-    <p:sldId id="258" r:id="rId9"/>
-    <p:sldId id="259" r:id="rId10"/>
-    <p:sldId id="260" r:id="rId11"/>
-    <p:sldId id="261" r:id="rId12"/>
-    <p:sldId id="262" r:id="rId13"/>
-    <p:sldId id="263" r:id="rId14"/>
-    <p:sldId id="264" r:id="rId15"/>
+    <p:sldId id="256" r:id="rId2"/>
+    <p:sldId id="257" r:id="rId3"/>
+    <p:sldId id="258" r:id="rId4"/>
+    <p:sldId id="259" r:id="rId5"/>
+    <p:sldId id="260" r:id="rId6"/>
+    <p:sldId id="261" r:id="rId7"/>
+    <p:sldId id="262" r:id="rId8"/>
+    <p:sldId id="263" r:id="rId9"/>
+    <p:sldId id="264" r:id="rId10"/>
   </p:sldIdLst>
-  <p:sldSz cx="12192000" cy="6858000" type="screen4x3"/>
+  <p:sldSz cx="12192000" cy="6858000"/>
   <p:notesSz cx="6858000" cy="9144000"/>
+  <p:embeddedFontLst>
+    <p:embeddedFont>
+      <p:font typeface="Geologica" pitchFamily="2" charset="0"/>
+      <p:regular r:id="rId11"/>
+      <p:bold r:id="rId12"/>
+    </p:embeddedFont>
+    <p:embeddedFont>
+      <p:font typeface="Geologica Medium" pitchFamily="2" charset="0"/>
+      <p:regular r:id="rId13"/>
+    </p:embeddedFont>
+    <p:embeddedFont>
+      <p:font typeface="Onest Light" pitchFamily="2" charset="0"/>
+      <p:regular r:id="rId14"/>
+    </p:embeddedFont>
+    <p:embeddedFont>
+      <p:font typeface="Onest Medium" pitchFamily="2" charset="0"/>
+      <p:regular r:id="rId15"/>
+    </p:embeddedFont>
+    <p:embeddedFont>
+      <p:font typeface="Onest Regular" pitchFamily="2" charset="0"/>
+      <p:bold r:id="rId16"/>
+    </p:embeddedFont>
+  </p:embeddedFontLst>
   <p:defaultTextStyle>
     <a:defPPr>
       <a:defRPr lang="en-US"/>
@@ -112,6 +135,22 @@
       </a:defRPr>
     </a:lvl9pPr>
   </p:defaultTextStyle>
+  <p:extLst>
+    <p:ext uri="{EFAFB233-063F-42B5-8137-9DF3F51BA10A}">
+      <p15:sldGuideLst xmlns:p15="http://schemas.microsoft.com/office/powerpoint/2012/main">
+        <p15:guide id="1" orient="horz" pos="2160">
+          <p15:clr>
+            <a:srgbClr val="A4A3A4"/>
+          </p15:clr>
+        </p15:guide>
+        <p15:guide id="2" pos="2880">
+          <p15:clr>
+            <a:srgbClr val="A4A3A4"/>
+          </p15:clr>
+        </p15:guide>
+      </p15:sldGuideLst>
+    </p:ext>
+  </p:extLst>
 </p:presentation>
 </file>
 
@@ -153,10 +192,9 @@
           <a:lstStyle/>
           <a:p>
             <a:r>
-              <a:rPr lang="en-US" smtClean="0"/>
+              <a:rPr lang="en-US"/>
               <a:t>Click to edit Master title style</a:t>
             </a:r>
-            <a:endParaRPr lang="en-US"/>
           </a:p>
         </p:txBody>
       </p:sp>
@@ -272,10 +310,9 @@
           </a:lstStyle>
           <a:p>
             <a:r>
-              <a:rPr lang="en-US" smtClean="0"/>
+              <a:rPr lang="en-US"/>
               <a:t>Click to edit Master subtitle style</a:t>
             </a:r>
-            <a:endParaRPr lang="en-US"/>
           </a:p>
         </p:txBody>
       </p:sp>
@@ -296,7 +333,7 @@
           <a:p>
             <a:fld id="{5BCAD085-E8A6-8845-BD4E-CB4CCA059FC4}" type="datetimeFigureOut">
               <a:rPr lang="en-US" smtClean="0"/>
-              <a:t>1/27/13</a:t>
+              <a:t>8/7/2026</a:t>
             </a:fld>
             <a:endParaRPr lang="en-US"/>
           </a:p>
@@ -338,7 +375,7 @@
           <a:p>
             <a:fld id="{C1FF6DA9-008F-8B48-92A6-B652298478BF}" type="slidenum">
               <a:rPr lang="en-US" smtClean="0"/>
-              <a:t>‹#›</a:t>
+              <a:t>‹№›</a:t>
             </a:fld>
             <a:endParaRPr lang="en-US"/>
           </a:p>
@@ -390,10 +427,9 @@
           <a:lstStyle/>
           <a:p>
             <a:r>
-              <a:rPr lang="en-US" smtClean="0"/>
+              <a:rPr lang="en-US"/>
               <a:t>Click to edit Master title style</a:t>
             </a:r>
-            <a:endParaRPr lang="en-US"/>
           </a:p>
         </p:txBody>
       </p:sp>
@@ -414,38 +450,37 @@
           <a:p>
             <a:pPr lvl="0"/>
             <a:r>
-              <a:rPr lang="en-US" smtClean="0"/>
+              <a:rPr lang="en-US"/>
               <a:t>Click to edit Master text styles</a:t>
             </a:r>
           </a:p>
           <a:p>
             <a:pPr lvl="1"/>
             <a:r>
-              <a:rPr lang="en-US" smtClean="0"/>
+              <a:rPr lang="en-US"/>
               <a:t>Second level</a:t>
             </a:r>
           </a:p>
           <a:p>
             <a:pPr lvl="2"/>
             <a:r>
-              <a:rPr lang="en-US" smtClean="0"/>
+              <a:rPr lang="en-US"/>
               <a:t>Third level</a:t>
             </a:r>
           </a:p>
           <a:p>
             <a:pPr lvl="3"/>
             <a:r>
-              <a:rPr lang="en-US" smtClean="0"/>
+              <a:rPr lang="en-US"/>
               <a:t>Fourth level</a:t>
             </a:r>
           </a:p>
           <a:p>
             <a:pPr lvl="4"/>
             <a:r>
-              <a:rPr lang="en-US" smtClean="0"/>
+              <a:rPr lang="en-US"/>
               <a:t>Fifth level</a:t>
             </a:r>
-            <a:endParaRPr lang="en-US"/>
           </a:p>
         </p:txBody>
       </p:sp>
@@ -466,7 +501,7 @@
           <a:p>
             <a:fld id="{5BCAD085-E8A6-8845-BD4E-CB4CCA059FC4}" type="datetimeFigureOut">
               <a:rPr lang="en-US" smtClean="0"/>
-              <a:t>1/27/13</a:t>
+              <a:t>8/7/2026</a:t>
             </a:fld>
             <a:endParaRPr lang="en-US"/>
           </a:p>
@@ -508,7 +543,7 @@
           <a:p>
             <a:fld id="{C1FF6DA9-008F-8B48-92A6-B652298478BF}" type="slidenum">
               <a:rPr lang="en-US" smtClean="0"/>
-              <a:t>‹#›</a:t>
+              <a:t>‹№›</a:t>
             </a:fld>
             <a:endParaRPr lang="en-US"/>
           </a:p>
@@ -565,10 +600,9 @@
           <a:lstStyle/>
           <a:p>
             <a:r>
-              <a:rPr lang="en-US" smtClean="0"/>
+              <a:rPr lang="en-US"/>
               <a:t>Click to edit Master title style</a:t>
             </a:r>
-            <a:endParaRPr lang="en-US"/>
           </a:p>
         </p:txBody>
       </p:sp>
@@ -594,38 +628,37 @@
           <a:p>
             <a:pPr lvl="0"/>
             <a:r>
-              <a:rPr lang="en-US" smtClean="0"/>
+              <a:rPr lang="en-US"/>
               <a:t>Click to edit Master text styles</a:t>
             </a:r>
           </a:p>
           <a:p>
             <a:pPr lvl="1"/>
             <a:r>
-              <a:rPr lang="en-US" smtClean="0"/>
+              <a:rPr lang="en-US"/>
               <a:t>Second level</a:t>
             </a:r>
           </a:p>
           <a:p>
             <a:pPr lvl="2"/>
             <a:r>
-              <a:rPr lang="en-US" smtClean="0"/>
+              <a:rPr lang="en-US"/>
               <a:t>Third level</a:t>
             </a:r>
           </a:p>
           <a:p>
             <a:pPr lvl="3"/>
             <a:r>
-              <a:rPr lang="en-US" smtClean="0"/>
+              <a:rPr lang="en-US"/>
               <a:t>Fourth level</a:t>
             </a:r>
           </a:p>
           <a:p>
             <a:pPr lvl="4"/>
             <a:r>
-              <a:rPr lang="en-US" smtClean="0"/>
+              <a:rPr lang="en-US"/>
               <a:t>Fifth level</a:t>
             </a:r>
-            <a:endParaRPr lang="en-US"/>
           </a:p>
         </p:txBody>
       </p:sp>
@@ -646,7 +679,7 @@
           <a:p>
             <a:fld id="{5BCAD085-E8A6-8845-BD4E-CB4CCA059FC4}" type="datetimeFigureOut">
               <a:rPr lang="en-US" smtClean="0"/>
-              <a:t>1/27/13</a:t>
+              <a:t>8/7/2026</a:t>
             </a:fld>
             <a:endParaRPr lang="en-US"/>
           </a:p>
@@ -688,7 +721,7 @@
           <a:p>
             <a:fld id="{C1FF6DA9-008F-8B48-92A6-B652298478BF}" type="slidenum">
               <a:rPr lang="en-US" smtClean="0"/>
-              <a:t>‹#›</a:t>
+              <a:t>‹№›</a:t>
             </a:fld>
             <a:endParaRPr lang="en-US"/>
           </a:p>
@@ -740,10 +773,9 @@
           <a:lstStyle/>
           <a:p>
             <a:r>
-              <a:rPr lang="en-US" smtClean="0"/>
+              <a:rPr lang="en-US"/>
               <a:t>Click to edit Master title style</a:t>
             </a:r>
-            <a:endParaRPr lang="en-US"/>
           </a:p>
         </p:txBody>
       </p:sp>
@@ -764,38 +796,37 @@
           <a:p>
             <a:pPr lvl="0"/>
             <a:r>
-              <a:rPr lang="en-US" smtClean="0"/>
+              <a:rPr lang="en-US"/>
               <a:t>Click to edit Master text styles</a:t>
             </a:r>
           </a:p>
           <a:p>
             <a:pPr lvl="1"/>
             <a:r>
-              <a:rPr lang="en-US" smtClean="0"/>
+              <a:rPr lang="en-US"/>
               <a:t>Second level</a:t>
             </a:r>
           </a:p>
           <a:p>
             <a:pPr lvl="2"/>
             <a:r>
-              <a:rPr lang="en-US" smtClean="0"/>
+              <a:rPr lang="en-US"/>
               <a:t>Third level</a:t>
             </a:r>
           </a:p>
           <a:p>
             <a:pPr lvl="3"/>
             <a:r>
-              <a:rPr lang="en-US" smtClean="0"/>
+              <a:rPr lang="en-US"/>
               <a:t>Fourth level</a:t>
             </a:r>
           </a:p>
           <a:p>
             <a:pPr lvl="4"/>
             <a:r>
-              <a:rPr lang="en-US" smtClean="0"/>
+              <a:rPr lang="en-US"/>
               <a:t>Fifth level</a:t>
             </a:r>
-            <a:endParaRPr lang="en-US"/>
           </a:p>
         </p:txBody>
       </p:sp>
@@ -816,7 +847,7 @@
           <a:p>
             <a:fld id="{5BCAD085-E8A6-8845-BD4E-CB4CCA059FC4}" type="datetimeFigureOut">
               <a:rPr lang="en-US" smtClean="0"/>
-              <a:t>1/27/13</a:t>
+              <a:t>8/7/2026</a:t>
             </a:fld>
             <a:endParaRPr lang="en-US"/>
           </a:p>
@@ -858,7 +889,7 @@
           <a:p>
             <a:fld id="{C1FF6DA9-008F-8B48-92A6-B652298478BF}" type="slidenum">
               <a:rPr lang="en-US" smtClean="0"/>
-              <a:t>‹#›</a:t>
+              <a:t>‹№›</a:t>
             </a:fld>
             <a:endParaRPr lang="en-US"/>
           </a:p>
@@ -919,10 +950,9 @@
           </a:lstStyle>
           <a:p>
             <a:r>
-              <a:rPr lang="en-US" smtClean="0"/>
+              <a:rPr lang="en-US"/>
               <a:t>Click to edit Master title style</a:t>
             </a:r>
-            <a:endParaRPr lang="en-US"/>
           </a:p>
         </p:txBody>
       </p:sp>
@@ -1039,7 +1069,7 @@
           <a:p>
             <a:pPr lvl="0"/>
             <a:r>
-              <a:rPr lang="en-US" smtClean="0"/>
+              <a:rPr lang="en-US"/>
               <a:t>Click to edit Master text styles</a:t>
             </a:r>
           </a:p>
@@ -1062,7 +1092,7 @@
           <a:p>
             <a:fld id="{5BCAD085-E8A6-8845-BD4E-CB4CCA059FC4}" type="datetimeFigureOut">
               <a:rPr lang="en-US" smtClean="0"/>
-              <a:t>1/27/13</a:t>
+              <a:t>8/7/2026</a:t>
             </a:fld>
             <a:endParaRPr lang="en-US"/>
           </a:p>
@@ -1104,7 +1134,7 @@
           <a:p>
             <a:fld id="{C1FF6DA9-008F-8B48-92A6-B652298478BF}" type="slidenum">
               <a:rPr lang="en-US" smtClean="0"/>
-              <a:t>‹#›</a:t>
+              <a:t>‹№›</a:t>
             </a:fld>
             <a:endParaRPr lang="en-US"/>
           </a:p>
@@ -1156,10 +1186,9 @@
           <a:lstStyle/>
           <a:p>
             <a:r>
-              <a:rPr lang="en-US" smtClean="0"/>
+              <a:rPr lang="en-US"/>
               <a:t>Click to edit Master title style</a:t>
             </a:r>
-            <a:endParaRPr lang="en-US"/>
           </a:p>
         </p:txBody>
       </p:sp>
@@ -1213,38 +1242,37 @@
           <a:p>
             <a:pPr lvl="0"/>
             <a:r>
-              <a:rPr lang="en-US" smtClean="0"/>
+              <a:rPr lang="en-US"/>
               <a:t>Click to edit Master text styles</a:t>
             </a:r>
           </a:p>
           <a:p>
             <a:pPr lvl="1"/>
             <a:r>
-              <a:rPr lang="en-US" smtClean="0"/>
+              <a:rPr lang="en-US"/>
               <a:t>Second level</a:t>
             </a:r>
           </a:p>
           <a:p>
             <a:pPr lvl="2"/>
             <a:r>
-              <a:rPr lang="en-US" smtClean="0"/>
+              <a:rPr lang="en-US"/>
               <a:t>Third level</a:t>
             </a:r>
           </a:p>
           <a:p>
             <a:pPr lvl="3"/>
             <a:r>
-              <a:rPr lang="en-US" smtClean="0"/>
+              <a:rPr lang="en-US"/>
               <a:t>Fourth level</a:t>
             </a:r>
           </a:p>
           <a:p>
             <a:pPr lvl="4"/>
             <a:r>
-              <a:rPr lang="en-US" smtClean="0"/>
+              <a:rPr lang="en-US"/>
               <a:t>Fifth level</a:t>
             </a:r>
-            <a:endParaRPr lang="en-US"/>
           </a:p>
         </p:txBody>
       </p:sp>
@@ -1298,38 +1326,37 @@
           <a:p>
             <a:pPr lvl="0"/>
             <a:r>
-              <a:rPr lang="en-US" smtClean="0"/>
+              <a:rPr lang="en-US"/>
               <a:t>Click to edit Master text styles</a:t>
             </a:r>
           </a:p>
           <a:p>
             <a:pPr lvl="1"/>
             <a:r>
-              <a:rPr lang="en-US" smtClean="0"/>
+              <a:rPr lang="en-US"/>
               <a:t>Second level</a:t>
             </a:r>
           </a:p>
           <a:p>
             <a:pPr lvl="2"/>
             <a:r>
-              <a:rPr lang="en-US" smtClean="0"/>
+              <a:rPr lang="en-US"/>
               <a:t>Third level</a:t>
             </a:r>
           </a:p>
           <a:p>
             <a:pPr lvl="3"/>
             <a:r>
-              <a:rPr lang="en-US" smtClean="0"/>
+              <a:rPr lang="en-US"/>
               <a:t>Fourth level</a:t>
             </a:r>
           </a:p>
           <a:p>
             <a:pPr lvl="4"/>
             <a:r>
-              <a:rPr lang="en-US" smtClean="0"/>
+              <a:rPr lang="en-US"/>
               <a:t>Fifth level</a:t>
             </a:r>
-            <a:endParaRPr lang="en-US"/>
           </a:p>
         </p:txBody>
       </p:sp>
@@ -1350,7 +1377,7 @@
           <a:p>
             <a:fld id="{5BCAD085-E8A6-8845-BD4E-CB4CCA059FC4}" type="datetimeFigureOut">
               <a:rPr lang="en-US" smtClean="0"/>
-              <a:t>1/27/13</a:t>
+              <a:t>8/7/2026</a:t>
             </a:fld>
             <a:endParaRPr lang="en-US"/>
           </a:p>
@@ -1392,7 +1419,7 @@
           <a:p>
             <a:fld id="{C1FF6DA9-008F-8B48-92A6-B652298478BF}" type="slidenum">
               <a:rPr lang="en-US" smtClean="0"/>
-              <a:t>‹#›</a:t>
+              <a:t>‹№›</a:t>
             </a:fld>
             <a:endParaRPr lang="en-US"/>
           </a:p>
@@ -1448,10 +1475,9 @@
           </a:lstStyle>
           <a:p>
             <a:r>
-              <a:rPr lang="en-US" smtClean="0"/>
+              <a:rPr lang="en-US"/>
               <a:t>Click to edit Master title style</a:t>
             </a:r>
-            <a:endParaRPr lang="en-US"/>
           </a:p>
         </p:txBody>
       </p:sp>
@@ -1514,7 +1540,7 @@
           <a:p>
             <a:pPr lvl="0"/>
             <a:r>
-              <a:rPr lang="en-US" smtClean="0"/>
+              <a:rPr lang="en-US"/>
               <a:t>Click to edit Master text styles</a:t>
             </a:r>
           </a:p>
@@ -1570,38 +1596,37 @@
           <a:p>
             <a:pPr lvl="0"/>
             <a:r>
-              <a:rPr lang="en-US" smtClean="0"/>
+              <a:rPr lang="en-US"/>
               <a:t>Click to edit Master text styles</a:t>
             </a:r>
           </a:p>
           <a:p>
             <a:pPr lvl="1"/>
             <a:r>
-              <a:rPr lang="en-US" smtClean="0"/>
+              <a:rPr lang="en-US"/>
               <a:t>Second level</a:t>
             </a:r>
           </a:p>
           <a:p>
             <a:pPr lvl="2"/>
             <a:r>
-              <a:rPr lang="en-US" smtClean="0"/>
+              <a:rPr lang="en-US"/>
               <a:t>Third level</a:t>
             </a:r>
           </a:p>
           <a:p>
             <a:pPr lvl="3"/>
             <a:r>
-              <a:rPr lang="en-US" smtClean="0"/>
+              <a:rPr lang="en-US"/>
               <a:t>Fourth level</a:t>
             </a:r>
           </a:p>
           <a:p>
             <a:pPr lvl="4"/>
             <a:r>
-              <a:rPr lang="en-US" smtClean="0"/>
+              <a:rPr lang="en-US"/>
               <a:t>Fifth level</a:t>
             </a:r>
-            <a:endParaRPr lang="en-US"/>
           </a:p>
         </p:txBody>
       </p:sp>
@@ -1664,7 +1689,7 @@
           <a:p>
             <a:pPr lvl="0"/>
             <a:r>
-              <a:rPr lang="en-US" smtClean="0"/>
+              <a:rPr lang="en-US"/>
               <a:t>Click to edit Master text styles</a:t>
             </a:r>
           </a:p>
@@ -1720,38 +1745,37 @@
           <a:p>
             <a:pPr lvl="0"/>
             <a:r>
-              <a:rPr lang="en-US" smtClean="0"/>
+              <a:rPr lang="en-US"/>
               <a:t>Click to edit Master text styles</a:t>
             </a:r>
           </a:p>
           <a:p>
             <a:pPr lvl="1"/>
             <a:r>
-              <a:rPr lang="en-US" smtClean="0"/>
+              <a:rPr lang="en-US"/>
               <a:t>Second level</a:t>
             </a:r>
           </a:p>
           <a:p>
             <a:pPr lvl="2"/>
             <a:r>
-              <a:rPr lang="en-US" smtClean="0"/>
+              <a:rPr lang="en-US"/>
               <a:t>Third level</a:t>
             </a:r>
           </a:p>
           <a:p>
             <a:pPr lvl="3"/>
             <a:r>
-              <a:rPr lang="en-US" smtClean="0"/>
+              <a:rPr lang="en-US"/>
               <a:t>Fourth level</a:t>
             </a:r>
           </a:p>
           <a:p>
             <a:pPr lvl="4"/>
             <a:r>
-              <a:rPr lang="en-US" smtClean="0"/>
+              <a:rPr lang="en-US"/>
               <a:t>Fifth level</a:t>
             </a:r>
-            <a:endParaRPr lang="en-US"/>
           </a:p>
         </p:txBody>
       </p:sp>
@@ -1772,7 +1796,7 @@
           <a:p>
             <a:fld id="{5BCAD085-E8A6-8845-BD4E-CB4CCA059FC4}" type="datetimeFigureOut">
               <a:rPr lang="en-US" smtClean="0"/>
-              <a:t>1/27/13</a:t>
+              <a:t>8/7/2026</a:t>
             </a:fld>
             <a:endParaRPr lang="en-US"/>
           </a:p>
@@ -1814,7 +1838,7 @@
           <a:p>
             <a:fld id="{C1FF6DA9-008F-8B48-92A6-B652298478BF}" type="slidenum">
               <a:rPr lang="en-US" smtClean="0"/>
-              <a:t>‹#›</a:t>
+              <a:t>‹№›</a:t>
             </a:fld>
             <a:endParaRPr lang="en-US"/>
           </a:p>
@@ -1866,10 +1890,9 @@
           <a:lstStyle/>
           <a:p>
             <a:r>
-              <a:rPr lang="en-US" smtClean="0"/>
+              <a:rPr lang="en-US"/>
               <a:t>Click to edit Master title style</a:t>
             </a:r>
-            <a:endParaRPr lang="en-US"/>
           </a:p>
         </p:txBody>
       </p:sp>
@@ -1890,7 +1913,7 @@
           <a:p>
             <a:fld id="{5BCAD085-E8A6-8845-BD4E-CB4CCA059FC4}" type="datetimeFigureOut">
               <a:rPr lang="en-US" smtClean="0"/>
-              <a:t>1/27/13</a:t>
+              <a:t>8/7/2026</a:t>
             </a:fld>
             <a:endParaRPr lang="en-US"/>
           </a:p>
@@ -1932,7 +1955,7 @@
           <a:p>
             <a:fld id="{C1FF6DA9-008F-8B48-92A6-B652298478BF}" type="slidenum">
               <a:rPr lang="en-US" smtClean="0"/>
-              <a:t>‹#›</a:t>
+              <a:t>‹№›</a:t>
             </a:fld>
             <a:endParaRPr lang="en-US"/>
           </a:p>
@@ -1985,7 +2008,7 @@
           <a:p>
             <a:fld id="{5BCAD085-E8A6-8845-BD4E-CB4CCA059FC4}" type="datetimeFigureOut">
               <a:rPr lang="en-US" smtClean="0"/>
-              <a:t>1/27/13</a:t>
+              <a:t>8/7/2026</a:t>
             </a:fld>
             <a:endParaRPr lang="en-US"/>
           </a:p>
@@ -2027,7 +2050,7 @@
           <a:p>
             <a:fld id="{C1FF6DA9-008F-8B48-92A6-B652298478BF}" type="slidenum">
               <a:rPr lang="en-US" smtClean="0"/>
-              <a:t>‹#›</a:t>
+              <a:t>‹№›</a:t>
             </a:fld>
             <a:endParaRPr lang="en-US"/>
           </a:p>
@@ -2088,10 +2111,9 @@
           </a:lstStyle>
           <a:p>
             <a:r>
-              <a:rPr lang="en-US" smtClean="0"/>
+              <a:rPr lang="en-US"/>
               <a:t>Click to edit Master title style</a:t>
             </a:r>
-            <a:endParaRPr lang="en-US"/>
           </a:p>
         </p:txBody>
       </p:sp>
@@ -2145,38 +2167,37 @@
           <a:p>
             <a:pPr lvl="0"/>
             <a:r>
-              <a:rPr lang="en-US" smtClean="0"/>
+              <a:rPr lang="en-US"/>
               <a:t>Click to edit Master text styles</a:t>
             </a:r>
           </a:p>
           <a:p>
             <a:pPr lvl="1"/>
             <a:r>
-              <a:rPr lang="en-US" smtClean="0"/>
+              <a:rPr lang="en-US"/>
               <a:t>Second level</a:t>
             </a:r>
           </a:p>
           <a:p>
             <a:pPr lvl="2"/>
             <a:r>
-              <a:rPr lang="en-US" smtClean="0"/>
+              <a:rPr lang="en-US"/>
               <a:t>Third level</a:t>
             </a:r>
           </a:p>
           <a:p>
             <a:pPr lvl="3"/>
             <a:r>
-              <a:rPr lang="en-US" smtClean="0"/>
+              <a:rPr lang="en-US"/>
               <a:t>Fourth level</a:t>
             </a:r>
           </a:p>
           <a:p>
             <a:pPr lvl="4"/>
             <a:r>
-              <a:rPr lang="en-US" smtClean="0"/>
+              <a:rPr lang="en-US"/>
               <a:t>Fifth level</a:t>
             </a:r>
-            <a:endParaRPr lang="en-US"/>
           </a:p>
         </p:txBody>
       </p:sp>
@@ -2239,7 +2260,7 @@
           <a:p>
             <a:pPr lvl="0"/>
             <a:r>
-              <a:rPr lang="en-US" smtClean="0"/>
+              <a:rPr lang="en-US"/>
               <a:t>Click to edit Master text styles</a:t>
             </a:r>
           </a:p>
@@ -2262,7 +2283,7 @@
           <a:p>
             <a:fld id="{5BCAD085-E8A6-8845-BD4E-CB4CCA059FC4}" type="datetimeFigureOut">
               <a:rPr lang="en-US" smtClean="0"/>
-              <a:t>1/27/13</a:t>
+              <a:t>8/7/2026</a:t>
             </a:fld>
             <a:endParaRPr lang="en-US"/>
           </a:p>
@@ -2304,7 +2325,7 @@
           <a:p>
             <a:fld id="{C1FF6DA9-008F-8B48-92A6-B652298478BF}" type="slidenum">
               <a:rPr lang="en-US" smtClean="0"/>
-              <a:t>‹#›</a:t>
+              <a:t>‹№›</a:t>
             </a:fld>
             <a:endParaRPr lang="en-US"/>
           </a:p>
@@ -2365,10 +2386,9 @@
           </a:lstStyle>
           <a:p>
             <a:r>
-              <a:rPr lang="en-US" smtClean="0"/>
+              <a:rPr lang="en-US"/>
               <a:t>Click to edit Master title style</a:t>
             </a:r>
-            <a:endParaRPr lang="en-US"/>
           </a:p>
         </p:txBody>
       </p:sp>
@@ -2492,7 +2512,7 @@
           <a:p>
             <a:pPr lvl="0"/>
             <a:r>
-              <a:rPr lang="en-US" smtClean="0"/>
+              <a:rPr lang="en-US"/>
               <a:t>Click to edit Master text styles</a:t>
             </a:r>
           </a:p>
@@ -2515,7 +2535,7 @@
           <a:p>
             <a:fld id="{5BCAD085-E8A6-8845-BD4E-CB4CCA059FC4}" type="datetimeFigureOut">
               <a:rPr lang="en-US" smtClean="0"/>
-              <a:t>1/27/13</a:t>
+              <a:t>8/7/2026</a:t>
             </a:fld>
             <a:endParaRPr lang="en-US"/>
           </a:p>
@@ -2557,7 +2577,7 @@
           <a:p>
             <a:fld id="{C1FF6DA9-008F-8B48-92A6-B652298478BF}" type="slidenum">
               <a:rPr lang="en-US" smtClean="0"/>
-              <a:t>‹#›</a:t>
+              <a:t>‹№›</a:t>
             </a:fld>
             <a:endParaRPr lang="en-US"/>
           </a:p>
@@ -2624,10 +2644,9 @@
           <a:lstStyle/>
           <a:p>
             <a:r>
-              <a:rPr lang="en-US" smtClean="0"/>
+              <a:rPr lang="en-US"/>
               <a:t>Click to edit Master title style</a:t>
             </a:r>
-            <a:endParaRPr lang="en-US"/>
           </a:p>
         </p:txBody>
       </p:sp>
@@ -2658,38 +2677,37 @@
           <a:p>
             <a:pPr lvl="0"/>
             <a:r>
-              <a:rPr lang="en-US" smtClean="0"/>
+              <a:rPr lang="en-US"/>
               <a:t>Click to edit Master text styles</a:t>
             </a:r>
           </a:p>
           <a:p>
             <a:pPr lvl="1"/>
             <a:r>
-              <a:rPr lang="en-US" smtClean="0"/>
+              <a:rPr lang="en-US"/>
               <a:t>Second level</a:t>
             </a:r>
           </a:p>
           <a:p>
             <a:pPr lvl="2"/>
             <a:r>
-              <a:rPr lang="en-US" smtClean="0"/>
+              <a:rPr lang="en-US"/>
               <a:t>Third level</a:t>
             </a:r>
           </a:p>
           <a:p>
             <a:pPr lvl="3"/>
             <a:r>
-              <a:rPr lang="en-US" smtClean="0"/>
+              <a:rPr lang="en-US"/>
               <a:t>Fourth level</a:t>
             </a:r>
           </a:p>
           <a:p>
             <a:pPr lvl="4"/>
             <a:r>
-              <a:rPr lang="en-US" smtClean="0"/>
+              <a:rPr lang="en-US"/>
               <a:t>Fifth level</a:t>
             </a:r>
-            <a:endParaRPr lang="en-US"/>
           </a:p>
         </p:txBody>
       </p:sp>
@@ -2728,7 +2746,7 @@
           <a:p>
             <a:fld id="{5BCAD085-E8A6-8845-BD4E-CB4CCA059FC4}" type="datetimeFigureOut">
               <a:rPr lang="en-US" smtClean="0"/>
-              <a:t>1/27/13</a:t>
+              <a:t>8/7/2026</a:t>
             </a:fld>
             <a:endParaRPr lang="en-US"/>
           </a:p>
@@ -2806,7 +2824,7 @@
           <a:p>
             <a:fld id="{C1FF6DA9-008F-8B48-92A6-B652298478BF}" type="slidenum">
               <a:rPr lang="en-US" smtClean="0"/>
-              <a:t>‹#›</a:t>
+              <a:t>‹№›</a:t>
             </a:fld>
             <a:endParaRPr lang="en-US"/>
           </a:p>
@@ -3087,7 +3105,7 @@
 </file>
 
 <file path=ppt/slides/slide1.xml><?xml version="1.0" encoding="utf-8"?>
-<p:sld xmlns:a="http://schemas.openxmlformats.org/drawingml/2006/main" xmlns:p="http://schemas.openxmlformats.org/presentationml/2006/main" xmlns:r="http://schemas.openxmlformats.org/officeDocument/2006/relationships">
+<p:sld xmlns:a="http://schemas.openxmlformats.org/drawingml/2006/main" xmlns:r="http://schemas.openxmlformats.org/officeDocument/2006/relationships" xmlns:p="http://schemas.openxmlformats.org/presentationml/2006/main">
   <p:cSld>
     <p:spTree>
       <p:nvGrpSpPr>
@@ -3095,7 +3113,14 @@
         <p:cNvGrpSpPr/>
         <p:nvPr/>
       </p:nvGrpSpPr>
-      <p:grpSpPr/>
+      <p:grpSpPr>
+        <a:xfrm>
+          <a:off x="0" y="0"/>
+          <a:ext cx="0" cy="0"/>
+          <a:chOff x="0" y="0"/>
+          <a:chExt cx="0" cy="0"/>
+        </a:xfrm>
+      </p:grpSpPr>
       <p:pic>
         <p:nvPicPr>
           <p:cNvPr id="2" name="Picture 1" descr="bg-slide1.png"/>
@@ -3223,7 +3248,7 @@
           <a:noFill/>
         </p:spPr>
         <p:txBody>
-          <a:bodyPr wrap="none" lIns="0" rIns="0" tIns="0" bIns="0" anchor="t">
+          <a:bodyPr wrap="none" lIns="0" tIns="0" rIns="0" bIns="0" anchor="t">
             <a:noAutofit/>
           </a:bodyPr>
           <a:lstStyle/>
@@ -3268,7 +3293,7 @@
           <a:noFill/>
         </p:spPr>
         <p:txBody>
-          <a:bodyPr wrap="none" lIns="0" rIns="0" tIns="0" bIns="0" anchor="t">
+          <a:bodyPr wrap="none" lIns="0" tIns="0" rIns="0" bIns="0" anchor="t">
             <a:noAutofit/>
           </a:bodyPr>
           <a:lstStyle/>
@@ -3313,7 +3338,7 @@
           <a:noFill/>
         </p:spPr>
         <p:txBody>
-          <a:bodyPr wrap="none" lIns="0" rIns="0" tIns="0" bIns="0" anchor="t">
+          <a:bodyPr wrap="none" lIns="0" tIns="0" rIns="0" bIns="0" anchor="t">
             <a:noAutofit/>
           </a:bodyPr>
           <a:lstStyle/>
@@ -3384,6 +3409,7 @@
           <a:lstStyle/>
           <a:p>
             <a:pPr algn="ctr"/>
+            <a:endParaRPr/>
           </a:p>
         </p:txBody>
       </p:sp>
@@ -3404,7 +3430,7 @@
           <a:noFill/>
         </p:spPr>
         <p:txBody>
-          <a:bodyPr wrap="none" lIns="0" rIns="0" tIns="0" bIns="0" anchor="ctr">
+          <a:bodyPr wrap="none" lIns="0" tIns="0" rIns="0" bIns="0" anchor="ctr">
             <a:noAutofit/>
           </a:bodyPr>
           <a:lstStyle/>
@@ -3449,7 +3475,7 @@
           <a:noFill/>
         </p:spPr>
         <p:txBody>
-          <a:bodyPr wrap="none" lIns="0" rIns="0" tIns="0" bIns="0" anchor="ctr">
+          <a:bodyPr wrap="none" lIns="0" tIns="0" rIns="0" bIns="0" anchor="ctr">
             <a:noAutofit/>
           </a:bodyPr>
           <a:lstStyle/>
@@ -3520,6 +3546,7 @@
           <a:lstStyle/>
           <a:p>
             <a:pPr algn="ctr"/>
+            <a:endParaRPr/>
           </a:p>
         </p:txBody>
       </p:sp>
@@ -3540,7 +3567,7 @@
           <a:noFill/>
         </p:spPr>
         <p:txBody>
-          <a:bodyPr wrap="none" lIns="0" rIns="0" tIns="0" bIns="0" anchor="ctr">
+          <a:bodyPr wrap="none" lIns="0" tIns="0" rIns="0" bIns="0" anchor="ctr">
             <a:noAutofit/>
           </a:bodyPr>
           <a:lstStyle/>
@@ -3585,7 +3612,7 @@
           <a:noFill/>
         </p:spPr>
         <p:txBody>
-          <a:bodyPr wrap="none" lIns="0" rIns="0" tIns="0" bIns="0" anchor="ctr">
+          <a:bodyPr wrap="none" lIns="0" tIns="0" rIns="0" bIns="0" anchor="ctr">
             <a:noAutofit/>
           </a:bodyPr>
           <a:lstStyle/>
@@ -3656,6 +3683,7 @@
           <a:lstStyle/>
           <a:p>
             <a:pPr algn="ctr"/>
+            <a:endParaRPr/>
           </a:p>
         </p:txBody>
       </p:sp>
@@ -3676,7 +3704,7 @@
           <a:noFill/>
         </p:spPr>
         <p:txBody>
-          <a:bodyPr wrap="none" lIns="0" rIns="0" tIns="0" bIns="0" anchor="ctr">
+          <a:bodyPr wrap="none" lIns="0" tIns="0" rIns="0" bIns="0" anchor="ctr">
             <a:noAutofit/>
           </a:bodyPr>
           <a:lstStyle/>
@@ -3721,7 +3749,7 @@
           <a:noFill/>
         </p:spPr>
         <p:txBody>
-          <a:bodyPr wrap="none" lIns="0" rIns="0" tIns="0" bIns="0" anchor="ctr">
+          <a:bodyPr wrap="none" lIns="0" tIns="0" rIns="0" bIns="0" anchor="ctr">
             <a:noAutofit/>
           </a:bodyPr>
           <a:lstStyle/>
@@ -3792,6 +3820,7 @@
           <a:lstStyle/>
           <a:p>
             <a:pPr algn="ctr"/>
+            <a:endParaRPr/>
           </a:p>
         </p:txBody>
       </p:sp>
@@ -3812,7 +3841,7 @@
           <a:noFill/>
         </p:spPr>
         <p:txBody>
-          <a:bodyPr wrap="none" lIns="0" rIns="0" tIns="0" bIns="0" anchor="ctr">
+          <a:bodyPr wrap="none" lIns="0" tIns="0" rIns="0" bIns="0" anchor="ctr">
             <a:noAutofit/>
           </a:bodyPr>
           <a:lstStyle/>
@@ -3857,7 +3886,7 @@
           <a:noFill/>
         </p:spPr>
         <p:txBody>
-          <a:bodyPr wrap="none" lIns="0" rIns="0" tIns="0" bIns="0" anchor="t">
+          <a:bodyPr wrap="none" lIns="0" tIns="0" rIns="0" bIns="0" anchor="t">
             <a:noAutofit/>
           </a:bodyPr>
           <a:lstStyle/>
@@ -3902,7 +3931,7 @@
           <a:noFill/>
         </p:spPr>
         <p:txBody>
-          <a:bodyPr wrap="none" lIns="0" rIns="0" tIns="0" bIns="0" anchor="t">
+          <a:bodyPr wrap="none" lIns="0" tIns="0" rIns="0" bIns="0" anchor="t">
             <a:noAutofit/>
           </a:bodyPr>
           <a:lstStyle/>
@@ -3947,7 +3976,7 @@
           <a:noFill/>
         </p:spPr>
         <p:txBody>
-          <a:bodyPr wrap="none" lIns="0" rIns="0" tIns="0" bIns="0" anchor="t">
+          <a:bodyPr wrap="none" lIns="0" tIns="0" rIns="0" bIns="0" anchor="t">
             <a:noAutofit/>
           </a:bodyPr>
           <a:lstStyle/>
@@ -3992,7 +4021,7 @@
           <a:noFill/>
         </p:spPr>
         <p:txBody>
-          <a:bodyPr wrap="none" lIns="0" rIns="0" tIns="0" bIns="0" anchor="t">
+          <a:bodyPr wrap="none" lIns="0" tIns="0" rIns="0" bIns="0" anchor="t">
             <a:noAutofit/>
           </a:bodyPr>
           <a:lstStyle/>
@@ -4065,13 +4094,6 @@
             <a:noFill/>
           </a:ln>
           <a:effectLst/>
-          <a:effectLst>
-            <a:outerShdw blurRad="127000" dist="25400" dir="5400000" rotWithShape="0">
-              <a:srgbClr val="394050">
-                <a:alpha val="12000"/>
-              </a:srgbClr>
-            </a:outerShdw>
-          </a:effectLst>
         </p:spPr>
         <p:style>
           <a:lnRef idx="1">
@@ -4092,6 +4114,7 @@
           <a:lstStyle/>
           <a:p>
             <a:pPr algn="ctr"/>
+            <a:endParaRPr/>
           </a:p>
         </p:txBody>
       </p:sp>
@@ -4160,7 +4183,7 @@
           <a:noFill/>
         </p:spPr>
         <p:txBody>
-          <a:bodyPr wrap="none" lIns="0" rIns="0" tIns="0" bIns="0" anchor="t">
+          <a:bodyPr wrap="none" lIns="0" tIns="0" rIns="0" bIns="0" anchor="t">
             <a:noAutofit/>
           </a:bodyPr>
           <a:lstStyle/>
@@ -4231,6 +4254,7 @@
           <a:lstStyle/>
           <a:p>
             <a:pPr algn="ctr"/>
+            <a:endParaRPr/>
           </a:p>
         </p:txBody>
       </p:sp>
@@ -4251,7 +4275,7 @@
           <a:noFill/>
         </p:spPr>
         <p:txBody>
-          <a:bodyPr wrap="none" lIns="0" rIns="0" tIns="0" bIns="0" anchor="ctr">
+          <a:bodyPr wrap="none" lIns="0" tIns="0" rIns="0" bIns="0" anchor="ctr">
             <a:noAutofit/>
           </a:bodyPr>
           <a:lstStyle/>
@@ -4296,7 +4320,7 @@
           <a:noFill/>
         </p:spPr>
         <p:txBody>
-          <a:bodyPr wrap="square" lIns="0" rIns="0" tIns="0" bIns="0" anchor="t">
+          <a:bodyPr wrap="square" lIns="0" tIns="0" rIns="0" bIns="0" anchor="t">
             <a:noAutofit/>
           </a:bodyPr>
           <a:lstStyle/>
@@ -4429,6 +4453,7 @@
           <a:lstStyle/>
           <a:p>
             <a:pPr algn="ctr"/>
+            <a:endParaRPr/>
           </a:p>
         </p:txBody>
       </p:sp>
@@ -4475,6 +4500,7 @@
           <a:lstStyle/>
           <a:p>
             <a:pPr algn="ctr"/>
+            <a:endParaRPr/>
           </a:p>
         </p:txBody>
       </p:sp>
@@ -4557,7 +4583,7 @@
           <a:noFill/>
         </p:spPr>
         <p:txBody>
-          <a:bodyPr wrap="none" lIns="0" rIns="0" tIns="0" bIns="0" anchor="ctr">
+          <a:bodyPr wrap="none" lIns="0" tIns="0" rIns="0" bIns="0" anchor="ctr">
             <a:noAutofit/>
           </a:bodyPr>
           <a:lstStyle/>
@@ -4594,7 +4620,7 @@
 </file>
 
 <file path=ppt/slides/slide2.xml><?xml version="1.0" encoding="utf-8"?>
-<p:sld xmlns:a="http://schemas.openxmlformats.org/drawingml/2006/main" xmlns:p="http://schemas.openxmlformats.org/presentationml/2006/main" xmlns:r="http://schemas.openxmlformats.org/officeDocument/2006/relationships">
+<p:sld xmlns:a="http://schemas.openxmlformats.org/drawingml/2006/main" xmlns:r="http://schemas.openxmlformats.org/officeDocument/2006/relationships" xmlns:p="http://schemas.openxmlformats.org/presentationml/2006/main">
   <p:cSld>
     <p:spTree>
       <p:nvGrpSpPr>
@@ -4602,7 +4628,14 @@
         <p:cNvGrpSpPr/>
         <p:nvPr/>
       </p:nvGrpSpPr>
-      <p:grpSpPr/>
+      <p:grpSpPr>
+        <a:xfrm>
+          <a:off x="0" y="0"/>
+          <a:ext cx="0" cy="0"/>
+          <a:chOff x="0" y="0"/>
+          <a:chExt cx="0" cy="0"/>
+        </a:xfrm>
+      </p:grpSpPr>
       <p:pic>
         <p:nvPicPr>
           <p:cNvPr id="2" name="Picture 1" descr="bg-slide2.png"/>
@@ -4644,7 +4677,7 @@
           <a:noFill/>
         </p:spPr>
         <p:txBody>
-          <a:bodyPr wrap="none" lIns="0" rIns="0" tIns="0" bIns="0" anchor="t">
+          <a:bodyPr wrap="none" lIns="0" tIns="0" rIns="0" bIns="0" anchor="t">
             <a:noAutofit/>
           </a:bodyPr>
           <a:lstStyle/>
@@ -4711,7 +4744,7 @@
           <a:noFill/>
         </p:spPr>
         <p:txBody>
-          <a:bodyPr wrap="none" lIns="0" rIns="0" tIns="0" bIns="0" anchor="t">
+          <a:bodyPr wrap="none" lIns="0" tIns="0" rIns="0" bIns="0" anchor="t">
             <a:noAutofit/>
           </a:bodyPr>
           <a:lstStyle/>
@@ -4794,7 +4827,7 @@
           <a:noFill/>
         </p:spPr>
         <p:txBody>
-          <a:bodyPr wrap="none" lIns="0" rIns="0" tIns="0" bIns="0" anchor="t">
+          <a:bodyPr wrap="none" lIns="0" tIns="0" rIns="0" bIns="0" anchor="t">
             <a:noAutofit/>
           </a:bodyPr>
           <a:lstStyle/>
@@ -4839,7 +4872,7 @@
           <a:noFill/>
         </p:spPr>
         <p:txBody>
-          <a:bodyPr wrap="none" lIns="0" rIns="0" tIns="0" bIns="0" anchor="t">
+          <a:bodyPr wrap="none" lIns="0" tIns="0" rIns="0" bIns="0" anchor="t">
             <a:noAutofit/>
           </a:bodyPr>
           <a:lstStyle/>
@@ -4884,7 +4917,7 @@
           <a:noFill/>
         </p:spPr>
         <p:txBody>
-          <a:bodyPr wrap="none" lIns="0" rIns="0" tIns="0" bIns="0" anchor="t">
+          <a:bodyPr wrap="none" lIns="0" tIns="0" rIns="0" bIns="0" anchor="t">
             <a:noAutofit/>
           </a:bodyPr>
           <a:lstStyle/>
@@ -4929,7 +4962,7 @@
           <a:noFill/>
         </p:spPr>
         <p:txBody>
-          <a:bodyPr wrap="square" lIns="0" rIns="0" tIns="0" bIns="0" anchor="t">
+          <a:bodyPr wrap="square" lIns="0" tIns="0" rIns="0" bIns="0" anchor="t">
             <a:noAutofit/>
           </a:bodyPr>
           <a:lstStyle/>
@@ -5038,6 +5071,7 @@
           <a:lstStyle/>
           <a:p>
             <a:pPr algn="ctr"/>
+            <a:endParaRPr/>
           </a:p>
         </p:txBody>
       </p:sp>
@@ -5058,7 +5092,7 @@
           <a:noFill/>
         </p:spPr>
         <p:txBody>
-          <a:bodyPr wrap="none" lIns="0" rIns="0" tIns="0" bIns="0" anchor="ctr">
+          <a:bodyPr wrap="none" lIns="0" tIns="0" rIns="0" bIns="0" anchor="ctr">
             <a:noAutofit/>
           </a:bodyPr>
           <a:lstStyle/>
@@ -5129,6 +5163,7 @@
           <a:lstStyle/>
           <a:p>
             <a:pPr algn="ctr"/>
+            <a:endParaRPr/>
           </a:p>
         </p:txBody>
       </p:sp>
@@ -5149,7 +5184,7 @@
           <a:noFill/>
         </p:spPr>
         <p:txBody>
-          <a:bodyPr wrap="none" lIns="0" rIns="0" tIns="0" bIns="0" anchor="ctr">
+          <a:bodyPr wrap="none" lIns="0" tIns="0" rIns="0" bIns="0" anchor="ctr">
             <a:noAutofit/>
           </a:bodyPr>
           <a:lstStyle/>
@@ -5220,6 +5255,7 @@
           <a:lstStyle/>
           <a:p>
             <a:pPr algn="ctr"/>
+            <a:endParaRPr/>
           </a:p>
         </p:txBody>
       </p:sp>
@@ -5240,7 +5276,7 @@
           <a:noFill/>
         </p:spPr>
         <p:txBody>
-          <a:bodyPr wrap="none" lIns="0" rIns="0" tIns="0" bIns="0" anchor="ctr">
+          <a:bodyPr wrap="none" lIns="0" tIns="0" rIns="0" bIns="0" anchor="ctr">
             <a:noAutofit/>
           </a:bodyPr>
           <a:lstStyle/>
@@ -5453,7 +5489,7 @@
           <a:noFill/>
         </p:spPr>
         <p:txBody>
-          <a:bodyPr wrap="none" lIns="0" rIns="0" tIns="0" bIns="0" anchor="t">
+          <a:bodyPr wrap="none" lIns="0" tIns="0" rIns="0" bIns="0" anchor="t">
             <a:noAutofit/>
           </a:bodyPr>
           <a:lstStyle/>
@@ -5522,7 +5558,7 @@
           <a:noFill/>
         </p:spPr>
         <p:txBody>
-          <a:bodyPr wrap="none" lIns="0" rIns="0" tIns="0" bIns="0" anchor="ctr">
+          <a:bodyPr wrap="none" lIns="0" tIns="0" rIns="0" bIns="0" anchor="ctr">
             <a:noAutofit/>
           </a:bodyPr>
           <a:lstStyle/>
@@ -5559,7 +5595,7 @@
 </file>
 
 <file path=ppt/slides/slide3.xml><?xml version="1.0" encoding="utf-8"?>
-<p:sld xmlns:a="http://schemas.openxmlformats.org/drawingml/2006/main" xmlns:p="http://schemas.openxmlformats.org/presentationml/2006/main" xmlns:r="http://schemas.openxmlformats.org/officeDocument/2006/relationships">
+<p:sld xmlns:a="http://schemas.openxmlformats.org/drawingml/2006/main" xmlns:r="http://schemas.openxmlformats.org/officeDocument/2006/relationships" xmlns:p="http://schemas.openxmlformats.org/presentationml/2006/main">
   <p:cSld>
     <p:spTree>
       <p:nvGrpSpPr>
@@ -5567,7 +5603,14 @@
         <p:cNvGrpSpPr/>
         <p:nvPr/>
       </p:nvGrpSpPr>
-      <p:grpSpPr/>
+      <p:grpSpPr>
+        <a:xfrm>
+          <a:off x="0" y="0"/>
+          <a:ext cx="0" cy="0"/>
+          <a:chOff x="0" y="0"/>
+          <a:chExt cx="0" cy="0"/>
+        </a:xfrm>
+      </p:grpSpPr>
       <p:pic>
         <p:nvPicPr>
           <p:cNvPr id="2" name="Picture 1" descr="bg-dark-plain.png"/>
@@ -5635,6 +5678,7 @@
           <a:lstStyle/>
           <a:p>
             <a:pPr algn="ctr"/>
+            <a:endParaRPr/>
           </a:p>
         </p:txBody>
       </p:sp>
@@ -5655,7 +5699,7 @@
           <a:noFill/>
         </p:spPr>
         <p:txBody>
-          <a:bodyPr wrap="none" lIns="0" rIns="0" tIns="0" bIns="0" anchor="ctr">
+          <a:bodyPr wrap="none" lIns="0" tIns="0" rIns="0" bIns="0" anchor="ctr">
             <a:noAutofit/>
           </a:bodyPr>
           <a:lstStyle/>
@@ -5700,7 +5744,7 @@
           <a:noFill/>
         </p:spPr>
         <p:txBody>
-          <a:bodyPr wrap="square" lIns="0" rIns="0" tIns="0" bIns="0" anchor="t">
+          <a:bodyPr wrap="square" lIns="0" tIns="0" rIns="0" bIns="0" anchor="t">
             <a:noAutofit/>
           </a:bodyPr>
           <a:lstStyle/>
@@ -5825,13 +5869,6 @@
             <a:noFill/>
           </a:ln>
           <a:effectLst/>
-          <a:effectLst>
-            <a:outerShdw blurRad="127000" dist="25400" dir="5400000" rotWithShape="0">
-              <a:srgbClr val="394050">
-                <a:alpha val="12000"/>
-              </a:srgbClr>
-            </a:outerShdw>
-          </a:effectLst>
         </p:spPr>
         <p:style>
           <a:lnRef idx="1">
@@ -5852,6 +5889,7 @@
           <a:lstStyle/>
           <a:p>
             <a:pPr algn="ctr"/>
+            <a:endParaRPr/>
           </a:p>
         </p:txBody>
       </p:sp>
@@ -5896,7 +5934,7 @@
           <a:noFill/>
         </p:spPr>
         <p:txBody>
-          <a:bodyPr wrap="none" lIns="0" rIns="0" tIns="0" bIns="0" anchor="t">
+          <a:bodyPr wrap="none" lIns="0" tIns="0" rIns="0" bIns="0" anchor="t">
             <a:noAutofit/>
           </a:bodyPr>
           <a:lstStyle/>
@@ -5941,7 +5979,7 @@
           <a:noFill/>
         </p:spPr>
         <p:txBody>
-          <a:bodyPr wrap="square" lIns="0" rIns="0" tIns="0" bIns="0" anchor="t">
+          <a:bodyPr wrap="square" lIns="0" tIns="0" rIns="0" bIns="0" anchor="t">
             <a:noAutofit/>
           </a:bodyPr>
           <a:lstStyle/>
@@ -5990,13 +6028,6 @@
             <a:noFill/>
           </a:ln>
           <a:effectLst/>
-          <a:effectLst>
-            <a:outerShdw blurRad="127000" dist="25400" dir="5400000" rotWithShape="0">
-              <a:srgbClr val="394050">
-                <a:alpha val="12000"/>
-              </a:srgbClr>
-            </a:outerShdw>
-          </a:effectLst>
         </p:spPr>
         <p:style>
           <a:lnRef idx="1">
@@ -6017,6 +6048,7 @@
           <a:lstStyle/>
           <a:p>
             <a:pPr algn="ctr"/>
+            <a:endParaRPr/>
           </a:p>
         </p:txBody>
       </p:sp>
@@ -6061,7 +6093,7 @@
           <a:noFill/>
         </p:spPr>
         <p:txBody>
-          <a:bodyPr wrap="none" lIns="0" rIns="0" tIns="0" bIns="0" anchor="t">
+          <a:bodyPr wrap="none" lIns="0" tIns="0" rIns="0" bIns="0" anchor="t">
             <a:noAutofit/>
           </a:bodyPr>
           <a:lstStyle/>
@@ -6106,7 +6138,7 @@
           <a:noFill/>
         </p:spPr>
         <p:txBody>
-          <a:bodyPr wrap="square" lIns="0" rIns="0" tIns="0" bIns="0" anchor="t">
+          <a:bodyPr wrap="square" lIns="0" tIns="0" rIns="0" bIns="0" anchor="t">
             <a:noAutofit/>
           </a:bodyPr>
           <a:lstStyle/>
@@ -6155,13 +6187,6 @@
             <a:noFill/>
           </a:ln>
           <a:effectLst/>
-          <a:effectLst>
-            <a:outerShdw blurRad="127000" dist="25400" dir="5400000" rotWithShape="0">
-              <a:srgbClr val="394050">
-                <a:alpha val="12000"/>
-              </a:srgbClr>
-            </a:outerShdw>
-          </a:effectLst>
         </p:spPr>
         <p:style>
           <a:lnRef idx="1">
@@ -6182,6 +6207,7 @@
           <a:lstStyle/>
           <a:p>
             <a:pPr algn="ctr"/>
+            <a:endParaRPr/>
           </a:p>
         </p:txBody>
       </p:sp>
@@ -6226,7 +6252,7 @@
           <a:noFill/>
         </p:spPr>
         <p:txBody>
-          <a:bodyPr wrap="none" lIns="0" rIns="0" tIns="0" bIns="0" anchor="t">
+          <a:bodyPr wrap="none" lIns="0" tIns="0" rIns="0" bIns="0" anchor="t">
             <a:noAutofit/>
           </a:bodyPr>
           <a:lstStyle/>
@@ -6271,7 +6297,7 @@
           <a:noFill/>
         </p:spPr>
         <p:txBody>
-          <a:bodyPr wrap="square" lIns="0" rIns="0" tIns="0" bIns="0" anchor="t">
+          <a:bodyPr wrap="square" lIns="0" tIns="0" rIns="0" bIns="0" anchor="t">
             <a:noAutofit/>
           </a:bodyPr>
           <a:lstStyle/>
@@ -6340,7 +6366,7 @@
           <a:noFill/>
         </p:spPr>
         <p:txBody>
-          <a:bodyPr wrap="none" lIns="0" rIns="0" tIns="0" bIns="0" anchor="ctr">
+          <a:bodyPr wrap="none" lIns="0" tIns="0" rIns="0" bIns="0" anchor="ctr">
             <a:noAutofit/>
           </a:bodyPr>
           <a:lstStyle/>
@@ -6377,7 +6403,7 @@
 </file>
 
 <file path=ppt/slides/slide4.xml><?xml version="1.0" encoding="utf-8"?>
-<p:sld xmlns:a="http://schemas.openxmlformats.org/drawingml/2006/main" xmlns:p="http://schemas.openxmlformats.org/presentationml/2006/main" xmlns:r="http://schemas.openxmlformats.org/officeDocument/2006/relationships">
+<p:sld xmlns:a="http://schemas.openxmlformats.org/drawingml/2006/main" xmlns:r="http://schemas.openxmlformats.org/officeDocument/2006/relationships" xmlns:p="http://schemas.openxmlformats.org/presentationml/2006/main">
   <p:cSld>
     <p:spTree>
       <p:nvGrpSpPr>
@@ -6385,7 +6411,14 @@
         <p:cNvGrpSpPr/>
         <p:nvPr/>
       </p:nvGrpSpPr>
-      <p:grpSpPr/>
+      <p:grpSpPr>
+        <a:xfrm>
+          <a:off x="0" y="0"/>
+          <a:ext cx="0" cy="0"/>
+          <a:chOff x="0" y="0"/>
+          <a:chExt cx="0" cy="0"/>
+        </a:xfrm>
+      </p:grpSpPr>
       <p:pic>
         <p:nvPicPr>
           <p:cNvPr id="2" name="Picture 1" descr="bg-light-plain.png"/>
@@ -6455,6 +6488,7 @@
           <a:lstStyle/>
           <a:p>
             <a:pPr algn="ctr"/>
+            <a:endParaRPr/>
           </a:p>
         </p:txBody>
       </p:sp>
@@ -6475,7 +6509,7 @@
           <a:noFill/>
         </p:spPr>
         <p:txBody>
-          <a:bodyPr wrap="none" lIns="0" rIns="0" tIns="0" bIns="0" anchor="ctr">
+          <a:bodyPr wrap="none" lIns="0" tIns="0" rIns="0" bIns="0" anchor="ctr">
             <a:noAutofit/>
           </a:bodyPr>
           <a:lstStyle/>
@@ -6520,7 +6554,7 @@
           <a:noFill/>
         </p:spPr>
         <p:txBody>
-          <a:bodyPr wrap="square" lIns="0" rIns="0" tIns="0" bIns="0" anchor="t">
+          <a:bodyPr wrap="square" lIns="0" tIns="0" rIns="0" bIns="0" anchor="t">
             <a:noAutofit/>
           </a:bodyPr>
           <a:lstStyle/>
@@ -6645,13 +6679,6 @@
             <a:noFill/>
           </a:ln>
           <a:effectLst/>
-          <a:effectLst>
-            <a:outerShdw blurRad="127000" dist="25400" dir="5400000" rotWithShape="0">
-              <a:srgbClr val="394050">
-                <a:alpha val="12000"/>
-              </a:srgbClr>
-            </a:outerShdw>
-          </a:effectLst>
         </p:spPr>
         <p:style>
           <a:lnRef idx="1">
@@ -6672,6 +6699,7 @@
           <a:lstStyle/>
           <a:p>
             <a:pPr algn="ctr"/>
+            <a:endParaRPr/>
           </a:p>
         </p:txBody>
       </p:sp>
@@ -6716,7 +6744,7 @@
           <a:noFill/>
         </p:spPr>
         <p:txBody>
-          <a:bodyPr wrap="square" lIns="0" rIns="0" tIns="0" bIns="0" anchor="t">
+          <a:bodyPr wrap="square" lIns="0" tIns="0" rIns="0" bIns="0" anchor="t">
             <a:noAutofit/>
           </a:bodyPr>
           <a:lstStyle/>
@@ -6761,7 +6789,7 @@
           <a:noFill/>
         </p:spPr>
         <p:txBody>
-          <a:bodyPr wrap="square" lIns="0" rIns="0" tIns="0" bIns="0" anchor="t">
+          <a:bodyPr wrap="square" lIns="0" tIns="0" rIns="0" bIns="0" anchor="t">
             <a:noAutofit/>
           </a:bodyPr>
           <a:lstStyle/>
@@ -6810,13 +6838,6 @@
             <a:noFill/>
           </a:ln>
           <a:effectLst/>
-          <a:effectLst>
-            <a:outerShdw blurRad="127000" dist="25400" dir="5400000" rotWithShape="0">
-              <a:srgbClr val="394050">
-                <a:alpha val="12000"/>
-              </a:srgbClr>
-            </a:outerShdw>
-          </a:effectLst>
         </p:spPr>
         <p:style>
           <a:lnRef idx="1">
@@ -6837,6 +6858,7 @@
           <a:lstStyle/>
           <a:p>
             <a:pPr algn="ctr"/>
+            <a:endParaRPr/>
           </a:p>
         </p:txBody>
       </p:sp>
@@ -6881,7 +6903,7 @@
           <a:noFill/>
         </p:spPr>
         <p:txBody>
-          <a:bodyPr wrap="square" lIns="0" rIns="0" tIns="0" bIns="0" anchor="t">
+          <a:bodyPr wrap="square" lIns="0" tIns="0" rIns="0" bIns="0" anchor="t">
             <a:noAutofit/>
           </a:bodyPr>
           <a:lstStyle/>
@@ -6926,7 +6948,7 @@
           <a:noFill/>
         </p:spPr>
         <p:txBody>
-          <a:bodyPr wrap="square" lIns="0" rIns="0" tIns="0" bIns="0" anchor="t">
+          <a:bodyPr wrap="square" lIns="0" tIns="0" rIns="0" bIns="0" anchor="t">
             <a:noAutofit/>
           </a:bodyPr>
           <a:lstStyle/>
@@ -6975,13 +6997,6 @@
             <a:noFill/>
           </a:ln>
           <a:effectLst/>
-          <a:effectLst>
-            <a:outerShdw blurRad="127000" dist="25400" dir="5400000" rotWithShape="0">
-              <a:srgbClr val="394050">
-                <a:alpha val="12000"/>
-              </a:srgbClr>
-            </a:outerShdw>
-          </a:effectLst>
         </p:spPr>
         <p:style>
           <a:lnRef idx="1">
@@ -7002,6 +7017,7 @@
           <a:lstStyle/>
           <a:p>
             <a:pPr algn="ctr"/>
+            <a:endParaRPr/>
           </a:p>
         </p:txBody>
       </p:sp>
@@ -7046,7 +7062,7 @@
           <a:noFill/>
         </p:spPr>
         <p:txBody>
-          <a:bodyPr wrap="square" lIns="0" rIns="0" tIns="0" bIns="0" anchor="t">
+          <a:bodyPr wrap="square" lIns="0" tIns="0" rIns="0" bIns="0" anchor="t">
             <a:noAutofit/>
           </a:bodyPr>
           <a:lstStyle/>
@@ -7091,7 +7107,7 @@
           <a:noFill/>
         </p:spPr>
         <p:txBody>
-          <a:bodyPr wrap="square" lIns="0" rIns="0" tIns="0" bIns="0" anchor="t">
+          <a:bodyPr wrap="square" lIns="0" tIns="0" rIns="0" bIns="0" anchor="t">
             <a:noAutofit/>
           </a:bodyPr>
           <a:lstStyle/>
@@ -7136,7 +7152,7 @@
           <a:noFill/>
         </p:spPr>
         <p:txBody>
-          <a:bodyPr wrap="none" lIns="0" rIns="0" tIns="0" bIns="0" anchor="t">
+          <a:bodyPr wrap="none" lIns="0" tIns="0" rIns="0" bIns="0" anchor="t">
             <a:noAutofit/>
           </a:bodyPr>
           <a:lstStyle/>
@@ -7205,7 +7221,7 @@
           <a:noFill/>
         </p:spPr>
         <p:txBody>
-          <a:bodyPr wrap="none" lIns="0" rIns="0" tIns="0" bIns="0" anchor="ctr">
+          <a:bodyPr wrap="none" lIns="0" tIns="0" rIns="0" bIns="0" anchor="ctr">
             <a:noAutofit/>
           </a:bodyPr>
           <a:lstStyle/>
@@ -7242,7 +7258,7 @@
 </file>
 
 <file path=ppt/slides/slide5.xml><?xml version="1.0" encoding="utf-8"?>
-<p:sld xmlns:a="http://schemas.openxmlformats.org/drawingml/2006/main" xmlns:p="http://schemas.openxmlformats.org/presentationml/2006/main" xmlns:r="http://schemas.openxmlformats.org/officeDocument/2006/relationships">
+<p:sld xmlns:a="http://schemas.openxmlformats.org/drawingml/2006/main" xmlns:r="http://schemas.openxmlformats.org/officeDocument/2006/relationships" xmlns:p="http://schemas.openxmlformats.org/presentationml/2006/main">
   <p:cSld>
     <p:spTree>
       <p:nvGrpSpPr>
@@ -7250,7 +7266,14 @@
         <p:cNvGrpSpPr/>
         <p:nvPr/>
       </p:nvGrpSpPr>
-      <p:grpSpPr/>
+      <p:grpSpPr>
+        <a:xfrm>
+          <a:off x="0" y="0"/>
+          <a:ext cx="0" cy="0"/>
+          <a:chOff x="0" y="0"/>
+          <a:chExt cx="0" cy="0"/>
+        </a:xfrm>
+      </p:grpSpPr>
       <p:pic>
         <p:nvPicPr>
           <p:cNvPr id="2" name="Picture 1" descr="bg-light-plain.png"/>
@@ -7320,6 +7343,7 @@
           <a:lstStyle/>
           <a:p>
             <a:pPr algn="ctr"/>
+            <a:endParaRPr/>
           </a:p>
         </p:txBody>
       </p:sp>
@@ -7340,7 +7364,7 @@
           <a:noFill/>
         </p:spPr>
         <p:txBody>
-          <a:bodyPr wrap="none" lIns="0" rIns="0" tIns="0" bIns="0" anchor="ctr">
+          <a:bodyPr wrap="none" lIns="0" tIns="0" rIns="0" bIns="0" anchor="ctr">
             <a:noAutofit/>
           </a:bodyPr>
           <a:lstStyle/>
@@ -7385,7 +7409,7 @@
           <a:noFill/>
         </p:spPr>
         <p:txBody>
-          <a:bodyPr wrap="square" lIns="0" rIns="0" tIns="0" bIns="0" anchor="t">
+          <a:bodyPr wrap="square" lIns="0" tIns="0" rIns="0" bIns="0" anchor="t">
             <a:noAutofit/>
           </a:bodyPr>
           <a:lstStyle/>
@@ -7472,13 +7496,6 @@
             <a:noFill/>
           </a:ln>
           <a:effectLst/>
-          <a:effectLst>
-            <a:outerShdw blurRad="127000" dist="25400" dir="5400000" rotWithShape="0">
-              <a:srgbClr val="394050">
-                <a:alpha val="12000"/>
-              </a:srgbClr>
-            </a:outerShdw>
-          </a:effectLst>
         </p:spPr>
         <p:style>
           <a:lnRef idx="1">
@@ -7499,6 +7516,7 @@
           <a:lstStyle/>
           <a:p>
             <a:pPr algn="ctr"/>
+            <a:endParaRPr/>
           </a:p>
         </p:txBody>
       </p:sp>
@@ -7543,7 +7561,7 @@
           <a:noFill/>
         </p:spPr>
         <p:txBody>
-          <a:bodyPr wrap="square" lIns="0" rIns="0" tIns="0" bIns="0" anchor="ctr">
+          <a:bodyPr wrap="square" lIns="0" tIns="0" rIns="0" bIns="0" anchor="ctr">
             <a:noAutofit/>
           </a:bodyPr>
           <a:lstStyle/>
@@ -7588,7 +7606,7 @@
           <a:noFill/>
         </p:spPr>
         <p:txBody>
-          <a:bodyPr wrap="square" lIns="0" rIns="0" tIns="0" bIns="0" anchor="ctr">
+          <a:bodyPr wrap="square" lIns="0" tIns="0" rIns="0" bIns="0" anchor="ctr">
             <a:noAutofit/>
           </a:bodyPr>
           <a:lstStyle/>
@@ -7675,13 +7693,6 @@
             <a:noFill/>
           </a:ln>
           <a:effectLst/>
-          <a:effectLst>
-            <a:outerShdw blurRad="127000" dist="25400" dir="5400000" rotWithShape="0">
-              <a:srgbClr val="394050">
-                <a:alpha val="12000"/>
-              </a:srgbClr>
-            </a:outerShdw>
-          </a:effectLst>
         </p:spPr>
         <p:style>
           <a:lnRef idx="1">
@@ -7702,6 +7713,7 @@
           <a:lstStyle/>
           <a:p>
             <a:pPr algn="ctr"/>
+            <a:endParaRPr/>
           </a:p>
         </p:txBody>
       </p:sp>
@@ -7746,7 +7758,7 @@
           <a:noFill/>
         </p:spPr>
         <p:txBody>
-          <a:bodyPr wrap="square" lIns="0" rIns="0" tIns="0" bIns="0" anchor="ctr">
+          <a:bodyPr wrap="square" lIns="0" tIns="0" rIns="0" bIns="0" anchor="ctr">
             <a:noAutofit/>
           </a:bodyPr>
           <a:lstStyle/>
@@ -7791,7 +7803,7 @@
           <a:noFill/>
         </p:spPr>
         <p:txBody>
-          <a:bodyPr wrap="square" lIns="0" rIns="0" tIns="0" bIns="0" anchor="ctr">
+          <a:bodyPr wrap="square" lIns="0" tIns="0" rIns="0" bIns="0" anchor="ctr">
             <a:noAutofit/>
           </a:bodyPr>
           <a:lstStyle/>
@@ -7878,13 +7890,6 @@
             <a:noFill/>
           </a:ln>
           <a:effectLst/>
-          <a:effectLst>
-            <a:outerShdw blurRad="127000" dist="25400" dir="5400000" rotWithShape="0">
-              <a:srgbClr val="394050">
-                <a:alpha val="12000"/>
-              </a:srgbClr>
-            </a:outerShdw>
-          </a:effectLst>
         </p:spPr>
         <p:style>
           <a:lnRef idx="1">
@@ -7905,6 +7910,7 @@
           <a:lstStyle/>
           <a:p>
             <a:pPr algn="ctr"/>
+            <a:endParaRPr/>
           </a:p>
         </p:txBody>
       </p:sp>
@@ -7949,7 +7955,7 @@
           <a:noFill/>
         </p:spPr>
         <p:txBody>
-          <a:bodyPr wrap="square" lIns="0" rIns="0" tIns="0" bIns="0" anchor="ctr">
+          <a:bodyPr wrap="square" lIns="0" tIns="0" rIns="0" bIns="0" anchor="ctr">
             <a:noAutofit/>
           </a:bodyPr>
           <a:lstStyle/>
@@ -7994,7 +8000,7 @@
           <a:noFill/>
         </p:spPr>
         <p:txBody>
-          <a:bodyPr wrap="square" lIns="0" rIns="0" tIns="0" bIns="0" anchor="ctr">
+          <a:bodyPr wrap="square" lIns="0" tIns="0" rIns="0" bIns="0" anchor="ctr">
             <a:noAutofit/>
           </a:bodyPr>
           <a:lstStyle/>
@@ -8119,13 +8125,6 @@
             <a:noFill/>
           </a:ln>
           <a:effectLst/>
-          <a:effectLst>
-            <a:outerShdw blurRad="127000" dist="25400" dir="5400000" rotWithShape="0">
-              <a:srgbClr val="394050">
-                <a:alpha val="12000"/>
-              </a:srgbClr>
-            </a:outerShdw>
-          </a:effectLst>
         </p:spPr>
         <p:style>
           <a:lnRef idx="1">
@@ -8146,6 +8145,7 @@
           <a:lstStyle/>
           <a:p>
             <a:pPr algn="ctr"/>
+            <a:endParaRPr/>
           </a:p>
         </p:txBody>
       </p:sp>
@@ -8190,7 +8190,7 @@
           <a:noFill/>
         </p:spPr>
         <p:txBody>
-          <a:bodyPr wrap="square" lIns="0" rIns="0" tIns="0" bIns="0" anchor="ctr">
+          <a:bodyPr wrap="square" lIns="0" tIns="0" rIns="0" bIns="0" anchor="ctr">
             <a:noAutofit/>
           </a:bodyPr>
           <a:lstStyle/>
@@ -8235,7 +8235,7 @@
           <a:noFill/>
         </p:spPr>
         <p:txBody>
-          <a:bodyPr wrap="square" lIns="0" rIns="0" tIns="0" bIns="0" anchor="ctr">
+          <a:bodyPr wrap="square" lIns="0" tIns="0" rIns="0" bIns="0" anchor="ctr">
             <a:noAutofit/>
           </a:bodyPr>
           <a:lstStyle/>
@@ -8304,7 +8304,7 @@
           <a:noFill/>
         </p:spPr>
         <p:txBody>
-          <a:bodyPr wrap="none" lIns="0" rIns="0" tIns="0" bIns="0" anchor="ctr">
+          <a:bodyPr wrap="none" lIns="0" tIns="0" rIns="0" bIns="0" anchor="ctr">
             <a:noAutofit/>
           </a:bodyPr>
           <a:lstStyle/>
@@ -8341,7 +8341,7 @@
 </file>
 
 <file path=ppt/slides/slide6.xml><?xml version="1.0" encoding="utf-8"?>
-<p:sld xmlns:a="http://schemas.openxmlformats.org/drawingml/2006/main" xmlns:p="http://schemas.openxmlformats.org/presentationml/2006/main" xmlns:r="http://schemas.openxmlformats.org/officeDocument/2006/relationships">
+<p:sld xmlns:a="http://schemas.openxmlformats.org/drawingml/2006/main" xmlns:r="http://schemas.openxmlformats.org/officeDocument/2006/relationships" xmlns:p="http://schemas.openxmlformats.org/presentationml/2006/main">
   <p:cSld>
     <p:spTree>
       <p:nvGrpSpPr>
@@ -8349,7 +8349,14 @@
         <p:cNvGrpSpPr/>
         <p:nvPr/>
       </p:nvGrpSpPr>
-      <p:grpSpPr/>
+      <p:grpSpPr>
+        <a:xfrm>
+          <a:off x="0" y="0"/>
+          <a:ext cx="0" cy="0"/>
+          <a:chOff x="0" y="0"/>
+          <a:chExt cx="0" cy="0"/>
+        </a:xfrm>
+      </p:grpSpPr>
       <p:pic>
         <p:nvPicPr>
           <p:cNvPr id="2" name="Picture 1" descr="bg-dark-plain.png"/>
@@ -8391,7 +8398,7 @@
           <a:noFill/>
         </p:spPr>
         <p:txBody>
-          <a:bodyPr wrap="none" lIns="0" rIns="0" tIns="0" bIns="0" anchor="t">
+          <a:bodyPr wrap="none" lIns="0" tIns="0" rIns="0" bIns="0" anchor="t">
             <a:noAutofit/>
           </a:bodyPr>
           <a:lstStyle/>
@@ -8472,7 +8479,7 @@
           <a:noFill/>
         </p:spPr>
         <p:txBody>
-          <a:bodyPr wrap="square" lIns="0" rIns="0" tIns="0" bIns="0" anchor="t">
+          <a:bodyPr wrap="square" lIns="0" tIns="0" rIns="0" bIns="0" anchor="t">
             <a:noAutofit/>
           </a:bodyPr>
           <a:lstStyle/>
@@ -8576,6 +8583,7 @@
           <a:lstStyle/>
           <a:p>
             <a:pPr algn="ctr"/>
+            <a:endParaRPr/>
           </a:p>
         </p:txBody>
       </p:sp>
@@ -8620,7 +8628,7 @@
           <a:noFill/>
         </p:spPr>
         <p:txBody>
-          <a:bodyPr wrap="none" lIns="0" rIns="0" tIns="0" bIns="0" anchor="t">
+          <a:bodyPr wrap="none" lIns="0" tIns="0" rIns="0" bIns="0" anchor="t">
             <a:noAutofit/>
           </a:bodyPr>
           <a:lstStyle/>
@@ -8665,7 +8673,7 @@
           <a:noFill/>
         </p:spPr>
         <p:txBody>
-          <a:bodyPr wrap="square" lIns="0" rIns="0" tIns="0" bIns="0" anchor="b">
+          <a:bodyPr wrap="square" lIns="0" tIns="0" rIns="0" bIns="0" anchor="b">
             <a:noAutofit/>
           </a:bodyPr>
           <a:lstStyle/>
@@ -8738,6 +8746,7 @@
           <a:lstStyle/>
           <a:p>
             <a:pPr algn="ctr"/>
+            <a:endParaRPr/>
           </a:p>
         </p:txBody>
       </p:sp>
@@ -8782,7 +8791,7 @@
           <a:noFill/>
         </p:spPr>
         <p:txBody>
-          <a:bodyPr wrap="none" lIns="0" rIns="0" tIns="0" bIns="0" anchor="t">
+          <a:bodyPr wrap="none" lIns="0" tIns="0" rIns="0" bIns="0" anchor="t">
             <a:noAutofit/>
           </a:bodyPr>
           <a:lstStyle/>
@@ -8827,7 +8836,7 @@
           <a:noFill/>
         </p:spPr>
         <p:txBody>
-          <a:bodyPr wrap="square" lIns="0" rIns="0" tIns="0" bIns="0" anchor="b">
+          <a:bodyPr wrap="square" lIns="0" tIns="0" rIns="0" bIns="0" anchor="b">
             <a:noAutofit/>
           </a:bodyPr>
           <a:lstStyle/>
@@ -8900,6 +8909,7 @@
           <a:lstStyle/>
           <a:p>
             <a:pPr algn="ctr"/>
+            <a:endParaRPr/>
           </a:p>
         </p:txBody>
       </p:sp>
@@ -8944,7 +8954,7 @@
           <a:noFill/>
         </p:spPr>
         <p:txBody>
-          <a:bodyPr wrap="none" lIns="0" rIns="0" tIns="0" bIns="0" anchor="t">
+          <a:bodyPr wrap="none" lIns="0" tIns="0" rIns="0" bIns="0" anchor="t">
             <a:noAutofit/>
           </a:bodyPr>
           <a:lstStyle/>
@@ -8989,7 +8999,7 @@
           <a:noFill/>
         </p:spPr>
         <p:txBody>
-          <a:bodyPr wrap="square" lIns="0" rIns="0" tIns="0" bIns="0" anchor="b">
+          <a:bodyPr wrap="square" lIns="0" tIns="0" rIns="0" bIns="0" anchor="b">
             <a:noAutofit/>
           </a:bodyPr>
           <a:lstStyle/>
@@ -9062,6 +9072,7 @@
           <a:lstStyle/>
           <a:p>
             <a:pPr algn="ctr"/>
+            <a:endParaRPr/>
           </a:p>
         </p:txBody>
       </p:sp>
@@ -9106,7 +9117,7 @@
           <a:noFill/>
         </p:spPr>
         <p:txBody>
-          <a:bodyPr wrap="none" lIns="0" rIns="0" tIns="0" bIns="0" anchor="t">
+          <a:bodyPr wrap="none" lIns="0" tIns="0" rIns="0" bIns="0" anchor="t">
             <a:noAutofit/>
           </a:bodyPr>
           <a:lstStyle/>
@@ -9151,7 +9162,7 @@
           <a:noFill/>
         </p:spPr>
         <p:txBody>
-          <a:bodyPr wrap="square" lIns="0" rIns="0" tIns="0" bIns="0" anchor="b">
+          <a:bodyPr wrap="square" lIns="0" tIns="0" rIns="0" bIns="0" anchor="b">
             <a:noAutofit/>
           </a:bodyPr>
           <a:lstStyle/>
@@ -9224,6 +9235,7 @@
           <a:lstStyle/>
           <a:p>
             <a:pPr algn="ctr"/>
+            <a:endParaRPr/>
           </a:p>
         </p:txBody>
       </p:sp>
@@ -9268,7 +9280,7 @@
           <a:noFill/>
         </p:spPr>
         <p:txBody>
-          <a:bodyPr wrap="none" lIns="0" rIns="0" tIns="0" bIns="0" anchor="t">
+          <a:bodyPr wrap="none" lIns="0" tIns="0" rIns="0" bIns="0" anchor="t">
             <a:noAutofit/>
           </a:bodyPr>
           <a:lstStyle/>
@@ -9313,7 +9325,7 @@
           <a:noFill/>
         </p:spPr>
         <p:txBody>
-          <a:bodyPr wrap="square" lIns="0" rIns="0" tIns="0" bIns="0" anchor="b">
+          <a:bodyPr wrap="square" lIns="0" tIns="0" rIns="0" bIns="0" anchor="b">
             <a:noAutofit/>
           </a:bodyPr>
           <a:lstStyle/>
@@ -9386,6 +9398,7 @@
           <a:lstStyle/>
           <a:p>
             <a:pPr algn="ctr"/>
+            <a:endParaRPr/>
           </a:p>
         </p:txBody>
       </p:sp>
@@ -9430,7 +9443,7 @@
           <a:noFill/>
         </p:spPr>
         <p:txBody>
-          <a:bodyPr wrap="none" lIns="0" rIns="0" tIns="0" bIns="0" anchor="t">
+          <a:bodyPr wrap="none" lIns="0" tIns="0" rIns="0" bIns="0" anchor="t">
             <a:noAutofit/>
           </a:bodyPr>
           <a:lstStyle/>
@@ -9475,7 +9488,7 @@
           <a:noFill/>
         </p:spPr>
         <p:txBody>
-          <a:bodyPr wrap="square" lIns="0" rIns="0" tIns="0" bIns="0" anchor="b">
+          <a:bodyPr wrap="square" lIns="0" tIns="0" rIns="0" bIns="0" anchor="b">
             <a:noAutofit/>
           </a:bodyPr>
           <a:lstStyle/>
@@ -9548,6 +9561,7 @@
           <a:lstStyle/>
           <a:p>
             <a:pPr algn="ctr"/>
+            <a:endParaRPr/>
           </a:p>
         </p:txBody>
       </p:sp>
@@ -9592,7 +9606,7 @@
           <a:noFill/>
         </p:spPr>
         <p:txBody>
-          <a:bodyPr wrap="none" lIns="0" rIns="0" tIns="0" bIns="0" anchor="t">
+          <a:bodyPr wrap="none" lIns="0" tIns="0" rIns="0" bIns="0" anchor="t">
             <a:noAutofit/>
           </a:bodyPr>
           <a:lstStyle/>
@@ -9637,7 +9651,7 @@
           <a:noFill/>
         </p:spPr>
         <p:txBody>
-          <a:bodyPr wrap="square" lIns="0" rIns="0" tIns="0" bIns="0" anchor="b">
+          <a:bodyPr wrap="square" lIns="0" tIns="0" rIns="0" bIns="0" anchor="b">
             <a:noAutofit/>
           </a:bodyPr>
           <a:lstStyle/>
@@ -9710,6 +9724,7 @@
           <a:lstStyle/>
           <a:p>
             <a:pPr algn="ctr"/>
+            <a:endParaRPr/>
           </a:p>
         </p:txBody>
       </p:sp>
@@ -9754,7 +9769,7 @@
           <a:noFill/>
         </p:spPr>
         <p:txBody>
-          <a:bodyPr wrap="none" lIns="0" rIns="0" tIns="0" bIns="0" anchor="t">
+          <a:bodyPr wrap="none" lIns="0" tIns="0" rIns="0" bIns="0" anchor="t">
             <a:noAutofit/>
           </a:bodyPr>
           <a:lstStyle/>
@@ -9799,7 +9814,7 @@
           <a:noFill/>
         </p:spPr>
         <p:txBody>
-          <a:bodyPr wrap="square" lIns="0" rIns="0" tIns="0" bIns="0" anchor="b">
+          <a:bodyPr wrap="square" lIns="0" tIns="0" rIns="0" bIns="0" anchor="b">
             <a:noAutofit/>
           </a:bodyPr>
           <a:lstStyle/>
@@ -9872,6 +9887,7 @@
           <a:lstStyle/>
           <a:p>
             <a:pPr algn="ctr"/>
+            <a:endParaRPr/>
           </a:p>
         </p:txBody>
       </p:sp>
@@ -9928,7 +9944,7 @@
           <a:noFill/>
         </p:spPr>
         <p:txBody>
-          <a:bodyPr wrap="square" lIns="0" rIns="0" tIns="0" bIns="0" anchor="ctr">
+          <a:bodyPr wrap="square" lIns="0" tIns="0" rIns="0" bIns="0" anchor="ctr">
             <a:noAutofit/>
           </a:bodyPr>
           <a:lstStyle/>
@@ -9997,7 +10013,7 @@
           <a:noFill/>
         </p:spPr>
         <p:txBody>
-          <a:bodyPr wrap="none" lIns="0" rIns="0" tIns="0" bIns="0" anchor="ctr">
+          <a:bodyPr wrap="none" lIns="0" tIns="0" rIns="0" bIns="0" anchor="ctr">
             <a:noAutofit/>
           </a:bodyPr>
           <a:lstStyle/>
@@ -10034,7 +10050,7 @@
 </file>
 
 <file path=ppt/slides/slide7.xml><?xml version="1.0" encoding="utf-8"?>
-<p:sld xmlns:a="http://schemas.openxmlformats.org/drawingml/2006/main" xmlns:p="http://schemas.openxmlformats.org/presentationml/2006/main" xmlns:r="http://schemas.openxmlformats.org/officeDocument/2006/relationships">
+<p:sld xmlns:a="http://schemas.openxmlformats.org/drawingml/2006/main" xmlns:r="http://schemas.openxmlformats.org/officeDocument/2006/relationships" xmlns:p="http://schemas.openxmlformats.org/presentationml/2006/main">
   <p:cSld>
     <p:spTree>
       <p:nvGrpSpPr>
@@ -10042,7 +10058,14 @@
         <p:cNvGrpSpPr/>
         <p:nvPr/>
       </p:nvGrpSpPr>
-      <p:grpSpPr/>
+      <p:grpSpPr>
+        <a:xfrm>
+          <a:off x="0" y="0"/>
+          <a:ext cx="0" cy="0"/>
+          <a:chOff x="0" y="0"/>
+          <a:chExt cx="0" cy="0"/>
+        </a:xfrm>
+      </p:grpSpPr>
       <p:pic>
         <p:nvPicPr>
           <p:cNvPr id="2" name="Picture 1" descr="bg-light-plain.png"/>
@@ -10108,6 +10131,7 @@
           <a:lstStyle/>
           <a:p>
             <a:pPr algn="ctr"/>
+            <a:endParaRPr/>
           </a:p>
         </p:txBody>
       </p:sp>
@@ -10192,6 +10216,7 @@
           <a:lstStyle/>
           <a:p>
             <a:pPr algn="ctr"/>
+            <a:endParaRPr/>
           </a:p>
         </p:txBody>
       </p:sp>
@@ -10212,7 +10237,7 @@
           <a:noFill/>
         </p:spPr>
         <p:txBody>
-          <a:bodyPr wrap="none" lIns="0" rIns="0" tIns="0" bIns="0" anchor="ctr">
+          <a:bodyPr wrap="none" lIns="0" tIns="0" rIns="0" bIns="0" anchor="ctr">
             <a:noAutofit/>
           </a:bodyPr>
           <a:lstStyle/>
@@ -10257,7 +10282,7 @@
           <a:noFill/>
         </p:spPr>
         <p:txBody>
-          <a:bodyPr wrap="square" lIns="0" rIns="0" tIns="0" bIns="0" anchor="t">
+          <a:bodyPr wrap="square" lIns="0" tIns="0" rIns="0" bIns="0" anchor="t">
             <a:noAutofit/>
           </a:bodyPr>
           <a:lstStyle/>
@@ -10328,6 +10353,7 @@
           <a:lstStyle/>
           <a:p>
             <a:pPr algn="ctr"/>
+            <a:endParaRPr/>
           </a:p>
         </p:txBody>
       </p:sp>
@@ -10348,7 +10374,7 @@
           <a:noFill/>
         </p:spPr>
         <p:txBody>
-          <a:bodyPr wrap="none" lIns="0" rIns="0" tIns="0" bIns="0" anchor="ctr">
+          <a:bodyPr wrap="none" lIns="0" tIns="0" rIns="0" bIns="0" anchor="ctr">
             <a:noAutofit/>
           </a:bodyPr>
           <a:lstStyle/>
@@ -10417,7 +10443,7 @@
           <a:noFill/>
         </p:spPr>
         <p:txBody>
-          <a:bodyPr wrap="square" lIns="0" rIns="0" tIns="0" bIns="0" anchor="ctr">
+          <a:bodyPr wrap="square" lIns="0" tIns="0" rIns="0" bIns="0" anchor="ctr">
             <a:noAutofit/>
           </a:bodyPr>
           <a:lstStyle/>
@@ -10486,7 +10512,7 @@
           <a:noFill/>
         </p:spPr>
         <p:txBody>
-          <a:bodyPr wrap="square" lIns="0" rIns="0" tIns="0" bIns="0" anchor="ctr">
+          <a:bodyPr wrap="square" lIns="0" tIns="0" rIns="0" bIns="0" anchor="ctr">
             <a:noAutofit/>
           </a:bodyPr>
           <a:lstStyle/>
@@ -10555,7 +10581,7 @@
           <a:noFill/>
         </p:spPr>
         <p:txBody>
-          <a:bodyPr wrap="square" lIns="0" rIns="0" tIns="0" bIns="0" anchor="ctr">
+          <a:bodyPr wrap="square" lIns="0" tIns="0" rIns="0" bIns="0" anchor="ctr">
             <a:noAutofit/>
           </a:bodyPr>
           <a:lstStyle/>
@@ -10624,7 +10650,7 @@
           <a:noFill/>
         </p:spPr>
         <p:txBody>
-          <a:bodyPr wrap="square" lIns="0" rIns="0" tIns="0" bIns="0" anchor="ctr">
+          <a:bodyPr wrap="square" lIns="0" tIns="0" rIns="0" bIns="0" anchor="ctr">
             <a:noAutofit/>
           </a:bodyPr>
           <a:lstStyle/>
@@ -10695,6 +10721,7 @@
           <a:lstStyle/>
           <a:p>
             <a:pPr algn="ctr"/>
+            <a:endParaRPr/>
           </a:p>
         </p:txBody>
       </p:sp>
@@ -10715,7 +10742,7 @@
           <a:noFill/>
         </p:spPr>
         <p:txBody>
-          <a:bodyPr wrap="none" lIns="0" rIns="0" tIns="0" bIns="0" anchor="ctr">
+          <a:bodyPr wrap="none" lIns="0" tIns="0" rIns="0" bIns="0" anchor="ctr">
             <a:noAutofit/>
           </a:bodyPr>
           <a:lstStyle/>
@@ -10784,7 +10811,7 @@
           <a:noFill/>
         </p:spPr>
         <p:txBody>
-          <a:bodyPr wrap="square" lIns="0" rIns="0" tIns="0" bIns="0" anchor="ctr">
+          <a:bodyPr wrap="square" lIns="0" tIns="0" rIns="0" bIns="0" anchor="ctr">
             <a:noAutofit/>
           </a:bodyPr>
           <a:lstStyle/>
@@ -10853,7 +10880,7 @@
           <a:noFill/>
         </p:spPr>
         <p:txBody>
-          <a:bodyPr wrap="square" lIns="0" rIns="0" tIns="0" bIns="0" anchor="ctr">
+          <a:bodyPr wrap="square" lIns="0" tIns="0" rIns="0" bIns="0" anchor="ctr">
             <a:noAutofit/>
           </a:bodyPr>
           <a:lstStyle/>
@@ -10922,7 +10949,7 @@
           <a:noFill/>
         </p:spPr>
         <p:txBody>
-          <a:bodyPr wrap="none" lIns="0" rIns="0" tIns="0" bIns="0" anchor="ctr">
+          <a:bodyPr wrap="none" lIns="0" tIns="0" rIns="0" bIns="0" anchor="ctr">
             <a:noAutofit/>
           </a:bodyPr>
           <a:lstStyle/>
@@ -10959,7 +10986,7 @@
 </file>
 
 <file path=ppt/slides/slide8.xml><?xml version="1.0" encoding="utf-8"?>
-<p:sld xmlns:a="http://schemas.openxmlformats.org/drawingml/2006/main" xmlns:p="http://schemas.openxmlformats.org/presentationml/2006/main" xmlns:r="http://schemas.openxmlformats.org/officeDocument/2006/relationships">
+<p:sld xmlns:a="http://schemas.openxmlformats.org/drawingml/2006/main" xmlns:r="http://schemas.openxmlformats.org/officeDocument/2006/relationships" xmlns:p="http://schemas.openxmlformats.org/presentationml/2006/main">
   <p:cSld>
     <p:spTree>
       <p:nvGrpSpPr>
@@ -10967,7 +10994,14 @@
         <p:cNvGrpSpPr/>
         <p:nvPr/>
       </p:nvGrpSpPr>
-      <p:grpSpPr/>
+      <p:grpSpPr>
+        <a:xfrm>
+          <a:off x="0" y="0"/>
+          <a:ext cx="0" cy="0"/>
+          <a:chOff x="0" y="0"/>
+          <a:chExt cx="0" cy="0"/>
+        </a:xfrm>
+      </p:grpSpPr>
       <p:pic>
         <p:nvPicPr>
           <p:cNvPr id="2" name="Picture 1" descr="bg-light-plain.png"/>
@@ -11037,6 +11071,7 @@
           <a:lstStyle/>
           <a:p>
             <a:pPr algn="ctr"/>
+            <a:endParaRPr/>
           </a:p>
         </p:txBody>
       </p:sp>
@@ -11057,7 +11092,7 @@
           <a:noFill/>
         </p:spPr>
         <p:txBody>
-          <a:bodyPr wrap="none" lIns="0" rIns="0" tIns="0" bIns="0" anchor="ctr">
+          <a:bodyPr wrap="none" lIns="0" tIns="0" rIns="0" bIns="0" anchor="ctr">
             <a:noAutofit/>
           </a:bodyPr>
           <a:lstStyle/>
@@ -11102,7 +11137,7 @@
           <a:noFill/>
         </p:spPr>
         <p:txBody>
-          <a:bodyPr wrap="none" lIns="0" rIns="0" tIns="0" bIns="0" anchor="t">
+          <a:bodyPr wrap="none" lIns="0" tIns="0" rIns="0" bIns="0" anchor="t">
             <a:noAutofit/>
           </a:bodyPr>
           <a:lstStyle/>
@@ -11147,7 +11182,7 @@
           <a:noFill/>
         </p:spPr>
         <p:txBody>
-          <a:bodyPr wrap="none" lIns="0" rIns="0" tIns="0" bIns="0" anchor="t">
+          <a:bodyPr wrap="none" lIns="0" tIns="0" rIns="0" bIns="0" anchor="t">
             <a:noAutofit/>
           </a:bodyPr>
           <a:lstStyle/>
@@ -11192,7 +11227,7 @@
           <a:noFill/>
         </p:spPr>
         <p:txBody>
-          <a:bodyPr wrap="square" lIns="0" rIns="0" tIns="0" bIns="0" anchor="t">
+          <a:bodyPr wrap="square" lIns="0" tIns="0" rIns="0" bIns="0" anchor="t">
             <a:noAutofit/>
           </a:bodyPr>
           <a:lstStyle/>
@@ -11237,7 +11272,7 @@
           <a:noFill/>
         </p:spPr>
         <p:txBody>
-          <a:bodyPr wrap="none" lIns="0" rIns="0" tIns="0" bIns="0" anchor="t">
+          <a:bodyPr wrap="none" lIns="0" tIns="0" rIns="0" bIns="0" anchor="t">
             <a:noAutofit/>
           </a:bodyPr>
           <a:lstStyle/>
@@ -11282,7 +11317,7 @@
           <a:noFill/>
         </p:spPr>
         <p:txBody>
-          <a:bodyPr wrap="square" lIns="0" rIns="0" tIns="0" bIns="0" anchor="t">
+          <a:bodyPr wrap="square" lIns="0" tIns="0" rIns="0" bIns="0" anchor="t">
             <a:noAutofit/>
           </a:bodyPr>
           <a:lstStyle/>
@@ -11327,7 +11362,7 @@
           <a:noFill/>
         </p:spPr>
         <p:txBody>
-          <a:bodyPr wrap="none" lIns="0" rIns="0" tIns="0" bIns="0" anchor="t">
+          <a:bodyPr wrap="none" lIns="0" tIns="0" rIns="0" bIns="0" anchor="t">
             <a:noAutofit/>
           </a:bodyPr>
           <a:lstStyle/>
@@ -11372,7 +11407,7 @@
           <a:noFill/>
         </p:spPr>
         <p:txBody>
-          <a:bodyPr wrap="square" lIns="0" rIns="0" tIns="0" bIns="0" anchor="t">
+          <a:bodyPr wrap="square" lIns="0" tIns="0" rIns="0" bIns="0" anchor="t">
             <a:noAutofit/>
           </a:bodyPr>
           <a:lstStyle/>
@@ -11770,13 +11805,6 @@
             <a:noFill/>
           </a:ln>
           <a:effectLst/>
-          <a:effectLst>
-            <a:outerShdw blurRad="127000" dist="25400" dir="5400000" rotWithShape="0">
-              <a:srgbClr val="394050">
-                <a:alpha val="12000"/>
-              </a:srgbClr>
-            </a:outerShdw>
-          </a:effectLst>
         </p:spPr>
         <p:style>
           <a:lnRef idx="1">
@@ -11797,6 +11825,7 @@
           <a:lstStyle/>
           <a:p>
             <a:pPr algn="ctr"/>
+            <a:endParaRPr/>
           </a:p>
         </p:txBody>
       </p:sp>
@@ -11841,7 +11870,7 @@
           <a:noFill/>
         </p:spPr>
         <p:txBody>
-          <a:bodyPr wrap="square" lIns="0" rIns="0" tIns="0" bIns="0" anchor="t">
+          <a:bodyPr wrap="square" lIns="0" tIns="0" rIns="0" bIns="0" anchor="t">
             <a:noAutofit/>
           </a:bodyPr>
           <a:lstStyle/>
@@ -11912,13 +11941,6 @@
             <a:noFill/>
           </a:ln>
           <a:effectLst/>
-          <a:effectLst>
-            <a:outerShdw blurRad="127000" dist="25400" dir="5400000" rotWithShape="0">
-              <a:srgbClr val="394050">
-                <a:alpha val="12000"/>
-              </a:srgbClr>
-            </a:outerShdw>
-          </a:effectLst>
         </p:spPr>
         <p:style>
           <a:lnRef idx="1">
@@ -11939,6 +11961,7 @@
           <a:lstStyle/>
           <a:p>
             <a:pPr algn="ctr"/>
+            <a:endParaRPr/>
           </a:p>
         </p:txBody>
       </p:sp>
@@ -11983,7 +12006,7 @@
           <a:noFill/>
         </p:spPr>
         <p:txBody>
-          <a:bodyPr wrap="square" lIns="0" rIns="0" tIns="0" bIns="0" anchor="t">
+          <a:bodyPr wrap="square" lIns="0" tIns="0" rIns="0" bIns="0" anchor="t">
             <a:noAutofit/>
           </a:bodyPr>
           <a:lstStyle/>
@@ -12054,13 +12077,6 @@
             <a:noFill/>
           </a:ln>
           <a:effectLst/>
-          <a:effectLst>
-            <a:outerShdw blurRad="127000" dist="25400" dir="5400000" rotWithShape="0">
-              <a:srgbClr val="394050">
-                <a:alpha val="12000"/>
-              </a:srgbClr>
-            </a:outerShdw>
-          </a:effectLst>
         </p:spPr>
         <p:style>
           <a:lnRef idx="1">
@@ -12081,6 +12097,7 @@
           <a:lstStyle/>
           <a:p>
             <a:pPr algn="ctr"/>
+            <a:endParaRPr/>
           </a:p>
         </p:txBody>
       </p:sp>
@@ -12125,7 +12142,7 @@
           <a:noFill/>
         </p:spPr>
         <p:txBody>
-          <a:bodyPr wrap="square" lIns="0" rIns="0" tIns="0" bIns="0" anchor="t">
+          <a:bodyPr wrap="square" lIns="0" tIns="0" rIns="0" bIns="0" anchor="t">
             <a:noAutofit/>
           </a:bodyPr>
           <a:lstStyle/>
@@ -12196,13 +12213,6 @@
             <a:noFill/>
           </a:ln>
           <a:effectLst/>
-          <a:effectLst>
-            <a:outerShdw blurRad="127000" dist="25400" dir="5400000" rotWithShape="0">
-              <a:srgbClr val="394050">
-                <a:alpha val="12000"/>
-              </a:srgbClr>
-            </a:outerShdw>
-          </a:effectLst>
         </p:spPr>
         <p:style>
           <a:lnRef idx="1">
@@ -12223,6 +12233,7 @@
           <a:lstStyle/>
           <a:p>
             <a:pPr algn="ctr"/>
+            <a:endParaRPr/>
           </a:p>
         </p:txBody>
       </p:sp>
@@ -12267,7 +12278,7 @@
           <a:noFill/>
         </p:spPr>
         <p:txBody>
-          <a:bodyPr wrap="square" lIns="0" rIns="0" tIns="0" bIns="0" anchor="t">
+          <a:bodyPr wrap="square" lIns="0" tIns="0" rIns="0" bIns="0" anchor="t">
             <a:noAutofit/>
           </a:bodyPr>
           <a:lstStyle/>
@@ -12358,7 +12369,7 @@
           <a:noFill/>
         </p:spPr>
         <p:txBody>
-          <a:bodyPr wrap="none" lIns="0" rIns="0" tIns="0" bIns="0" anchor="ctr">
+          <a:bodyPr wrap="none" lIns="0" tIns="0" rIns="0" bIns="0" anchor="ctr">
             <a:noAutofit/>
           </a:bodyPr>
           <a:lstStyle/>
@@ -12395,7 +12406,7 @@
 </file>
 
 <file path=ppt/slides/slide9.xml><?xml version="1.0" encoding="utf-8"?>
-<p:sld xmlns:a="http://schemas.openxmlformats.org/drawingml/2006/main" xmlns:p="http://schemas.openxmlformats.org/presentationml/2006/main" xmlns:r="http://schemas.openxmlformats.org/officeDocument/2006/relationships">
+<p:sld xmlns:a="http://schemas.openxmlformats.org/drawingml/2006/main" xmlns:r="http://schemas.openxmlformats.org/officeDocument/2006/relationships" xmlns:p="http://schemas.openxmlformats.org/presentationml/2006/main">
   <p:cSld>
     <p:spTree>
       <p:nvGrpSpPr>
@@ -12403,7 +12414,14 @@
         <p:cNvGrpSpPr/>
         <p:nvPr/>
       </p:nvGrpSpPr>
-      <p:grpSpPr/>
+      <p:grpSpPr>
+        <a:xfrm>
+          <a:off x="0" y="0"/>
+          <a:ext cx="0" cy="0"/>
+          <a:chOff x="0" y="0"/>
+          <a:chExt cx="0" cy="0"/>
+        </a:xfrm>
+      </p:grpSpPr>
       <p:pic>
         <p:nvPicPr>
           <p:cNvPr id="2" name="Picture 1" descr="bg-dark-plain.png"/>
@@ -12483,7 +12501,7 @@
           <a:noFill/>
         </p:spPr>
         <p:txBody>
-          <a:bodyPr wrap="none" lIns="0" rIns="0" tIns="0" bIns="0" anchor="t">
+          <a:bodyPr wrap="none" lIns="0" tIns="0" rIns="0" bIns="0" anchor="t">
             <a:noAutofit/>
           </a:bodyPr>
           <a:lstStyle/>
@@ -12577,6 +12595,7 @@
           <a:lstStyle/>
           <a:p>
             <a:pPr algn="ctr"/>
+            <a:endParaRPr/>
           </a:p>
         </p:txBody>
       </p:sp>
@@ -12623,6 +12642,7 @@
           <a:lstStyle/>
           <a:p>
             <a:pPr algn="ctr"/>
+            <a:endParaRPr/>
           </a:p>
         </p:txBody>
       </p:sp>
@@ -12643,7 +12663,7 @@
           <a:noFill/>
         </p:spPr>
         <p:txBody>
-          <a:bodyPr wrap="none" lIns="0" rIns="0" tIns="0" bIns="0" anchor="ctr">
+          <a:bodyPr wrap="none" lIns="0" tIns="0" rIns="0" bIns="0" anchor="ctr">
             <a:noAutofit/>
           </a:bodyPr>
           <a:lstStyle/>
@@ -12688,7 +12708,7 @@
           <a:noFill/>
         </p:spPr>
         <p:txBody>
-          <a:bodyPr wrap="none" lIns="0" rIns="0" tIns="0" bIns="0" anchor="t">
+          <a:bodyPr wrap="none" lIns="0" tIns="0" rIns="0" bIns="0" anchor="t">
             <a:noAutofit/>
           </a:bodyPr>
           <a:lstStyle/>
@@ -12733,7 +12753,7 @@
           <a:noFill/>
         </p:spPr>
         <p:txBody>
-          <a:bodyPr wrap="none" lIns="0" rIns="0" tIns="0" bIns="0" anchor="t">
+          <a:bodyPr wrap="none" lIns="0" tIns="0" rIns="0" bIns="0" anchor="t">
             <a:noAutofit/>
           </a:bodyPr>
           <a:lstStyle/>
@@ -12778,7 +12798,7 @@
           <a:noFill/>
         </p:spPr>
         <p:txBody>
-          <a:bodyPr wrap="none" lIns="0" rIns="0" tIns="0" bIns="0" anchor="t">
+          <a:bodyPr wrap="none" lIns="0" tIns="0" rIns="0" bIns="0" anchor="t">
             <a:noAutofit/>
           </a:bodyPr>
           <a:lstStyle/>
@@ -12850,6 +12870,7 @@
           <a:lstStyle/>
           <a:p>
             <a:pPr algn="ctr"/>
+            <a:endParaRPr/>
           </a:p>
         </p:txBody>
       </p:sp>
@@ -12896,6 +12917,7 @@
           <a:lstStyle/>
           <a:p>
             <a:pPr algn="ctr"/>
+            <a:endParaRPr/>
           </a:p>
         </p:txBody>
       </p:sp>
@@ -12916,7 +12938,7 @@
           <a:noFill/>
         </p:spPr>
         <p:txBody>
-          <a:bodyPr wrap="none" lIns="0" rIns="0" tIns="0" bIns="0" anchor="ctr">
+          <a:bodyPr wrap="none" lIns="0" tIns="0" rIns="0" bIns="0" anchor="ctr">
             <a:noAutofit/>
           </a:bodyPr>
           <a:lstStyle/>
@@ -12961,7 +12983,7 @@
           <a:noFill/>
         </p:spPr>
         <p:txBody>
-          <a:bodyPr wrap="none" lIns="0" rIns="0" tIns="0" bIns="0" anchor="t">
+          <a:bodyPr wrap="none" lIns="0" tIns="0" rIns="0" bIns="0" anchor="t">
             <a:noAutofit/>
           </a:bodyPr>
           <a:lstStyle/>
@@ -13030,7 +13052,7 @@
           <a:noFill/>
         </p:spPr>
         <p:txBody>
-          <a:bodyPr wrap="none" lIns="0" rIns="0" tIns="0" bIns="0" anchor="ctr">
+          <a:bodyPr wrap="none" lIns="0" tIns="0" rIns="0" bIns="0" anchor="ctr">
             <a:noAutofit/>
           </a:bodyPr>
           <a:lstStyle/>

</xml_diff>